<commit_message>
Add ISO 27001/27017/27018 certification cost to 5-year O&M cost slide
Year 1 initial certification S$8,000; Years 2, 3, 5 surveillance (1/3) and
Year 4 recertification (2/3) per the ISO/IEC 17021-1 three-year cycle, with
the 5% escalation. Subtotals, totals and KPI cards recalculated; first KPI
now shows the average operating cost per year.

Co-Authored-By: Claude Opus 5.5 <noreply@anthropic.com>
Claude-Session: https://claude.ai/code/session_01PXQJmBNUMSdyaspgXAoeg9
</commit_message>
<xml_diff>
--- a/KTPH_Annual_OM_Cost_Slide.pptx
+++ b/KTPH_Annual_OM_Cost_Slide.pptx
@@ -107,7 +107,7 @@
   <p:extLst>
     <p:ext uri="{521415D9-36F7-43E2-AB2F-B90AF26B5E84}">
       <p14:sectionLst xmlns:p14="http://schemas.microsoft.com/office/powerpoint/2010/main">
-        <p14:section name="3 · Smart diaper system" id="{1be50aa3-15fa-afdc-7115-08769a798f13}">
+        <p14:section name="3 · Smart diaper system" id="{fb51254b-d17e-17ae-b8ef-907f9b28a92d}">
           <p14:sldIdLst>
             <p14:sldId id="256"/>
           </p14:sldIdLst>
@@ -517,6 +517,7 @@
             <a:r>
               <a:rPr lang="en-US" dirty="0"/>
               <a:t>Source: Maintenance_Cost_Basis_v2_EN.xlsx, sheet 'Annual Cost Schedule' (figures recalculated in build_cost_slide.js from the Year-1 inputs and the 5.0% escalation; they reproduce the sheet exactly).
+ISO/IEC 27001/27017/27018 (added 2026-10-07): Year 1 initial certification S$8,000; Years 2, 3, 5 surveillance audits at 1/3 and Year 4 recertification at 2/3 of the initial audit (ISO/IEC 17021-1 / IAF MD 5 three-year cycle), plus the 5% escalation. Note the public Data Protection Notice states certification is targeted for H1 2027.
 Labour is charged once: total O&amp;M labour of 36,000 in Year 1 = Item 6 preventive maintenance 19,200 + subscription portion 16,800 (sheet 'Labour Split Check').
 Escalation of 5% is built in because MA Clause 13.1 does not permit the Charges to be adjusted during the term.
 OPEN POINTS BEFORE ISSUE (internal - do not show to KTPH): (1) The Summary sheet says Year-1 penetration testing was removed (Year-1 operating cost 76,800; five-year operating 454,539; total 468,825), but the Annual Cost Schedule still carries 12,000 in Year 1 (88,800; 466,539; 480,825) and its own remark says the pre-deployment test is absorbed in the System price. This slide follows the schedule; set PENTEST_Y1 = 0 in build_cost_slide.js to follow the Summary. (2) Initial set-up 14,285.71 has no derivation; shown in amber. (3) The Summary header says WH 40 sensors (140 total) while the contract draft total is 135 (KTPH 60 / TTSH 40 / WH 35). (4) The cost is 2.16x the Oct 2025 quotation (210,000 over five years); the Remarks Wording sheet attributes this to the Synapxe cloud security requirements. Keep the INTERNAL action-list sheet out of any external copy.</a:t>
@@ -1151,7 +1152,7 @@
                   <a:schemeClr val="tx2"/>
                 </a:solidFill>
               </a:rPr>
-              <a:t>Five-year operating and maintenance cost is S$466.5k, with 5% annual escalation built in so charges stay fixed</a:t>
+              <a:t>Five-year operating and maintenance cost is S$489.7k, with 5% annual escalation built in so charges stay fixed</a:t>
             </a:r>
             <a:endParaRPr lang="en-US" sz="2200" dirty="0"/>
           </a:p>
@@ -1165,8 +1166,8 @@
         </p:nvSpPr>
         <p:spPr>
           <a:xfrm>
-            <a:off x="548640" y="6199632"/>
-            <a:ext cx="11064240" cy="201168"/>
+            <a:off x="548640" y="6035040"/>
+            <a:ext cx="11064240" cy="365760"/>
           </a:xfrm>
           <a:prstGeom prst="rect">
             <a:avLst/>
@@ -1187,7 +1188,7 @@
                   <a:schemeClr val="accent4"/>
                 </a:solidFill>
               </a:rPr>
-              <a:t>Source: MONIT cost basis (Rev. 2, 16 Sep 2026); Master Agreement Clause 13.1 (Charges fixed for the term). SGD, ex-GST, rounded; 5.0% a year from Year 2.</a:t>
+              <a:t>Source: MONIT cost basis (Rev. 2, 16 Sep 2026); Master Agreement Clause 13.1 (Charges fixed for the term). SGD, ex-GST, rounded; 5.0% a year from Year 2. ISO: Y1 initial certification; Y2, Y3, Y5 surveillance (1/3) and Y4 recertification (2/3) of the initial audit, per ISO/IEC 17021-1.</a:t>
             </a:r>
             <a:endParaRPr lang="en-US" sz="900" dirty="0"/>
           </a:p>
@@ -1290,7 +1291,7 @@
                 <a:ea typeface="Cambria" pitchFamily="34" charset="-122"/>
                 <a:cs typeface="Cambria" pitchFamily="34" charset="-120"/>
               </a:rPr>
-              <a:t>S$88.8k</a:t>
+              <a:t>S$97.9k</a:t>
             </a:r>
             <a:endParaRPr lang="en-US" sz="2600" dirty="0"/>
           </a:p>
@@ -1326,7 +1327,7 @@
                   <a:schemeClr val="accent4"/>
                 </a:solidFill>
               </a:rPr>
-              <a:t>Year-1 operating cost</a:t>
+              <a:t>Average operating cost / year</a:t>
             </a:r>
             <a:endParaRPr lang="en-US" sz="1100" dirty="0"/>
           </a:p>
@@ -1429,7 +1430,7 @@
                 <a:ea typeface="Cambria" pitchFamily="34" charset="-122"/>
                 <a:cs typeface="Cambria" pitchFamily="34" charset="-120"/>
               </a:rPr>
-              <a:t>S$466.5k</a:t>
+              <a:t>S$489.7k</a:t>
             </a:r>
             <a:endParaRPr lang="en-US" sz="2600" dirty="0"/>
           </a:p>
@@ -1568,7 +1569,7 @@
                 <a:ea typeface="Cambria" pitchFamily="34" charset="-122"/>
                 <a:cs typeface="Cambria" pitchFamily="34" charset="-120"/>
               </a:rPr>
-              <a:t>S$364.5k</a:t>
+              <a:t>S$387.7k</a:t>
             </a:r>
             <a:endParaRPr lang="en-US" sz="2600" dirty="0"/>
           </a:p>
@@ -1604,7 +1605,7 @@
                   <a:schemeClr val="accent4"/>
                 </a:solidFill>
               </a:rPr>
-              <a:t>Annual subscription (78% of total)</a:t>
+              <a:t>Annual subscription (79% of total)</a:t>
             </a:r>
             <a:endParaRPr lang="en-US" sz="1100" dirty="0"/>
           </a:p>
@@ -1743,7 +1744,7 @@
                   <a:schemeClr val="accent4"/>
                 </a:solidFill>
               </a:rPr>
-              <a:t>Preventive maintenance (22% of total)</a:t>
+              <a:t>Preventive maintenance (21% of total)</a:t>
             </a:r>
             <a:endParaRPr lang="en-US" sz="1100" dirty="0"/>
           </a:p>
@@ -1780,7 +1781,7 @@
                 <a:gridCol w="758952"/>
                 <a:gridCol w="1234440"/>
               </a:tblGrid>
-              <a:tr h="283464">
+              <a:tr h="265176">
                 <a:tc>
                   <a:txBody>
                     <a:bodyPr/>
@@ -2041,7 +2042,7 @@
                   </a:tcPr>
                 </a:tc>
               </a:tr>
-              <a:tr h="283464">
+              <a:tr h="265176">
                 <a:tc>
                   <a:txBody>
                     <a:bodyPr/>
@@ -2344,7 +2345,7 @@
                   </a:tcPr>
                 </a:tc>
               </a:tr>
-              <a:tr h="283464">
+              <a:tr h="265176">
                 <a:tc>
                   <a:txBody>
                     <a:bodyPr/>
@@ -2647,7 +2648,7 @@
                   </a:tcPr>
                 </a:tc>
               </a:tr>
-              <a:tr h="283464">
+              <a:tr h="265176">
                 <a:tc>
                   <a:txBody>
                     <a:bodyPr/>
@@ -2950,7 +2951,7 @@
                   </a:tcPr>
                 </a:tc>
               </a:tr>
-              <a:tr h="283464">
+              <a:tr h="265176">
                 <a:tc>
                   <a:txBody>
                     <a:bodyPr/>
@@ -3253,7 +3254,7 @@
                   </a:tcPr>
                 </a:tc>
               </a:tr>
-              <a:tr h="283464">
+              <a:tr h="265176">
                 <a:tc>
                   <a:txBody>
                     <a:bodyPr/>
@@ -3268,6 +3269,309 @@
                             <a:srgbClr val="1F2937"/>
                           </a:solidFill>
                         </a:rPr>
+                        <a:t>ISO 27001/27017/27018 certification &amp; audits</a:t>
+                      </a:r>
+                      <a:endParaRPr lang="en-US" sz="1050" dirty="0"/>
+                    </a:p>
+                  </a:txBody>
+                  <a:tcPr marL="73152" marR="73152" marT="27432" marB="27432" anchor="ctr">
+                    <a:lnL w="0" cap="flat" cmpd="sng" algn="ctr">
+                      <a:noFill/>
+                    </a:lnL>
+                    <a:lnR w="0" cap="flat" cmpd="sng" algn="ctr">
+                      <a:noFill/>
+                    </a:lnR>
+                    <a:lnT w="0" cap="flat" cmpd="sng" algn="ctr">
+                      <a:noFill/>
+                    </a:lnT>
+                    <a:lnB w="9525" cap="flat" cmpd="sng" algn="ctr">
+                      <a:solidFill>
+                        <a:srgbClr val="D5DCE6"/>
+                      </a:solidFill>
+                      <a:prstDash val="solid"/>
+                      <a:round/>
+                      <a:headEnd type="none" w="med" len="med"/>
+                      <a:tailEnd type="none" w="med" len="med"/>
+                    </a:lnB>
+                    <a:solidFill>
+                      <a:srgbClr val="FFFFFF"/>
+                    </a:solidFill>
+                  </a:tcPr>
+                </a:tc>
+                <a:tc>
+                  <a:txBody>
+                    <a:bodyPr/>
+                    <a:lstStyle/>
+                    <a:p>
+                      <a:pPr algn="r" indent="0" marL="0">
+                        <a:buNone/>
+                      </a:pPr>
+                      <a:r>
+                        <a:rPr lang="en-US" sz="1050" dirty="0">
+                          <a:solidFill>
+                            <a:srgbClr val="1F2937"/>
+                          </a:solidFill>
+                        </a:rPr>
+                        <a:t>8,000</a:t>
+                      </a:r>
+                      <a:endParaRPr lang="en-US" sz="1050" dirty="0"/>
+                    </a:p>
+                  </a:txBody>
+                  <a:tcPr marL="73152" marR="73152" marT="27432" marB="27432" anchor="ctr">
+                    <a:lnL w="0" cap="flat" cmpd="sng" algn="ctr">
+                      <a:noFill/>
+                    </a:lnL>
+                    <a:lnR w="0" cap="flat" cmpd="sng" algn="ctr">
+                      <a:noFill/>
+                    </a:lnR>
+                    <a:lnT w="0" cap="flat" cmpd="sng" algn="ctr">
+                      <a:noFill/>
+                    </a:lnT>
+                    <a:lnB w="9525" cap="flat" cmpd="sng" algn="ctr">
+                      <a:solidFill>
+                        <a:srgbClr val="D5DCE6"/>
+                      </a:solidFill>
+                      <a:prstDash val="solid"/>
+                      <a:round/>
+                      <a:headEnd type="none" w="med" len="med"/>
+                      <a:tailEnd type="none" w="med" len="med"/>
+                    </a:lnB>
+                    <a:solidFill>
+                      <a:srgbClr val="FFFFFF"/>
+                    </a:solidFill>
+                  </a:tcPr>
+                </a:tc>
+                <a:tc>
+                  <a:txBody>
+                    <a:bodyPr/>
+                    <a:lstStyle/>
+                    <a:p>
+                      <a:pPr algn="r" indent="0" marL="0">
+                        <a:buNone/>
+                      </a:pPr>
+                      <a:r>
+                        <a:rPr lang="en-US" sz="1050" dirty="0">
+                          <a:solidFill>
+                            <a:srgbClr val="1F2937"/>
+                          </a:solidFill>
+                        </a:rPr>
+                        <a:t>2,800</a:t>
+                      </a:r>
+                      <a:endParaRPr lang="en-US" sz="1050" dirty="0"/>
+                    </a:p>
+                  </a:txBody>
+                  <a:tcPr marL="73152" marR="73152" marT="27432" marB="27432" anchor="ctr">
+                    <a:lnL w="0" cap="flat" cmpd="sng" algn="ctr">
+                      <a:noFill/>
+                    </a:lnL>
+                    <a:lnR w="0" cap="flat" cmpd="sng" algn="ctr">
+                      <a:noFill/>
+                    </a:lnR>
+                    <a:lnT w="0" cap="flat" cmpd="sng" algn="ctr">
+                      <a:noFill/>
+                    </a:lnT>
+                    <a:lnB w="9525" cap="flat" cmpd="sng" algn="ctr">
+                      <a:solidFill>
+                        <a:srgbClr val="D5DCE6"/>
+                      </a:solidFill>
+                      <a:prstDash val="solid"/>
+                      <a:round/>
+                      <a:headEnd type="none" w="med" len="med"/>
+                      <a:tailEnd type="none" w="med" len="med"/>
+                    </a:lnB>
+                    <a:solidFill>
+                      <a:srgbClr val="FFFFFF"/>
+                    </a:solidFill>
+                  </a:tcPr>
+                </a:tc>
+                <a:tc>
+                  <a:txBody>
+                    <a:bodyPr/>
+                    <a:lstStyle/>
+                    <a:p>
+                      <a:pPr algn="r" indent="0" marL="0">
+                        <a:buNone/>
+                      </a:pPr>
+                      <a:r>
+                        <a:rPr lang="en-US" sz="1050" dirty="0">
+                          <a:solidFill>
+                            <a:srgbClr val="1F2937"/>
+                          </a:solidFill>
+                        </a:rPr>
+                        <a:t>2,940</a:t>
+                      </a:r>
+                      <a:endParaRPr lang="en-US" sz="1050" dirty="0"/>
+                    </a:p>
+                  </a:txBody>
+                  <a:tcPr marL="73152" marR="73152" marT="27432" marB="27432" anchor="ctr">
+                    <a:lnL w="0" cap="flat" cmpd="sng" algn="ctr">
+                      <a:noFill/>
+                    </a:lnL>
+                    <a:lnR w="0" cap="flat" cmpd="sng" algn="ctr">
+                      <a:noFill/>
+                    </a:lnR>
+                    <a:lnT w="0" cap="flat" cmpd="sng" algn="ctr">
+                      <a:noFill/>
+                    </a:lnT>
+                    <a:lnB w="9525" cap="flat" cmpd="sng" algn="ctr">
+                      <a:solidFill>
+                        <a:srgbClr val="D5DCE6"/>
+                      </a:solidFill>
+                      <a:prstDash val="solid"/>
+                      <a:round/>
+                      <a:headEnd type="none" w="med" len="med"/>
+                      <a:tailEnd type="none" w="med" len="med"/>
+                    </a:lnB>
+                    <a:solidFill>
+                      <a:srgbClr val="FFFFFF"/>
+                    </a:solidFill>
+                  </a:tcPr>
+                </a:tc>
+                <a:tc>
+                  <a:txBody>
+                    <a:bodyPr/>
+                    <a:lstStyle/>
+                    <a:p>
+                      <a:pPr algn="r" indent="0" marL="0">
+                        <a:buNone/>
+                      </a:pPr>
+                      <a:r>
+                        <a:rPr lang="en-US" sz="1050" dirty="0">
+                          <a:solidFill>
+                            <a:srgbClr val="1F2937"/>
+                          </a:solidFill>
+                        </a:rPr>
+                        <a:t>6,174</a:t>
+                      </a:r>
+                      <a:endParaRPr lang="en-US" sz="1050" dirty="0"/>
+                    </a:p>
+                  </a:txBody>
+                  <a:tcPr marL="73152" marR="73152" marT="27432" marB="27432" anchor="ctr">
+                    <a:lnL w="0" cap="flat" cmpd="sng" algn="ctr">
+                      <a:noFill/>
+                    </a:lnL>
+                    <a:lnR w="0" cap="flat" cmpd="sng" algn="ctr">
+                      <a:noFill/>
+                    </a:lnR>
+                    <a:lnT w="0" cap="flat" cmpd="sng" algn="ctr">
+                      <a:noFill/>
+                    </a:lnT>
+                    <a:lnB w="9525" cap="flat" cmpd="sng" algn="ctr">
+                      <a:solidFill>
+                        <a:srgbClr val="D5DCE6"/>
+                      </a:solidFill>
+                      <a:prstDash val="solid"/>
+                      <a:round/>
+                      <a:headEnd type="none" w="med" len="med"/>
+                      <a:tailEnd type="none" w="med" len="med"/>
+                    </a:lnB>
+                    <a:solidFill>
+                      <a:srgbClr val="FFFFFF"/>
+                    </a:solidFill>
+                  </a:tcPr>
+                </a:tc>
+                <a:tc>
+                  <a:txBody>
+                    <a:bodyPr/>
+                    <a:lstStyle/>
+                    <a:p>
+                      <a:pPr algn="r" indent="0" marL="0">
+                        <a:buNone/>
+                      </a:pPr>
+                      <a:r>
+                        <a:rPr lang="en-US" sz="1050" dirty="0">
+                          <a:solidFill>
+                            <a:srgbClr val="1F2937"/>
+                          </a:solidFill>
+                        </a:rPr>
+                        <a:t>3,241</a:t>
+                      </a:r>
+                      <a:endParaRPr lang="en-US" sz="1050" dirty="0"/>
+                    </a:p>
+                  </a:txBody>
+                  <a:tcPr marL="73152" marR="73152" marT="27432" marB="27432" anchor="ctr">
+                    <a:lnL w="0" cap="flat" cmpd="sng" algn="ctr">
+                      <a:noFill/>
+                    </a:lnL>
+                    <a:lnR w="0" cap="flat" cmpd="sng" algn="ctr">
+                      <a:noFill/>
+                    </a:lnR>
+                    <a:lnT w="0" cap="flat" cmpd="sng" algn="ctr">
+                      <a:noFill/>
+                    </a:lnT>
+                    <a:lnB w="9525" cap="flat" cmpd="sng" algn="ctr">
+                      <a:solidFill>
+                        <a:srgbClr val="D5DCE6"/>
+                      </a:solidFill>
+                      <a:prstDash val="solid"/>
+                      <a:round/>
+                      <a:headEnd type="none" w="med" len="med"/>
+                      <a:tailEnd type="none" w="med" len="med"/>
+                    </a:lnB>
+                    <a:solidFill>
+                      <a:srgbClr val="FFFFFF"/>
+                    </a:solidFill>
+                  </a:tcPr>
+                </a:tc>
+                <a:tc>
+                  <a:txBody>
+                    <a:bodyPr/>
+                    <a:lstStyle/>
+                    <a:p>
+                      <a:pPr algn="r" indent="0" marL="0">
+                        <a:buNone/>
+                      </a:pPr>
+                      <a:r>
+                        <a:rPr lang="en-US" sz="1050" b="1" dirty="0">
+                          <a:solidFill>
+                            <a:srgbClr val="1F2937"/>
+                          </a:solidFill>
+                        </a:rPr>
+                        <a:t>23,155</a:t>
+                      </a:r>
+                      <a:endParaRPr lang="en-US" sz="1050" dirty="0"/>
+                    </a:p>
+                  </a:txBody>
+                  <a:tcPr marL="73152" marR="73152" marT="27432" marB="27432" anchor="ctr">
+                    <a:lnL w="0" cap="flat" cmpd="sng" algn="ctr">
+                      <a:noFill/>
+                    </a:lnL>
+                    <a:lnR w="0" cap="flat" cmpd="sng" algn="ctr">
+                      <a:noFill/>
+                    </a:lnR>
+                    <a:lnT w="0" cap="flat" cmpd="sng" algn="ctr">
+                      <a:noFill/>
+                    </a:lnT>
+                    <a:lnB w="9525" cap="flat" cmpd="sng" algn="ctr">
+                      <a:solidFill>
+                        <a:srgbClr val="D5DCE6"/>
+                      </a:solidFill>
+                      <a:prstDash val="solid"/>
+                      <a:round/>
+                      <a:headEnd type="none" w="med" len="med"/>
+                      <a:tailEnd type="none" w="med" len="med"/>
+                    </a:lnB>
+                    <a:solidFill>
+                      <a:srgbClr val="FFFFFF"/>
+                    </a:solidFill>
+                  </a:tcPr>
+                </a:tc>
+              </a:tr>
+              <a:tr h="265176">
+                <a:tc>
+                  <a:txBody>
+                    <a:bodyPr/>
+                    <a:lstStyle/>
+                    <a:p>
+                      <a:pPr indent="0" marL="0">
+                        <a:buNone/>
+                      </a:pPr>
+                      <a:r>
+                        <a:rPr lang="en-US" sz="1050" dirty="0">
+                          <a:solidFill>
+                            <a:srgbClr val="1F2937"/>
+                          </a:solidFill>
+                        </a:rPr>
                         <a:t>Remote support &amp; 24×7 monitoring</a:t>
                       </a:r>
                       <a:endParaRPr lang="en-US" sz="1050" dirty="0"/>
@@ -3293,6 +3597,612 @@
                       <a:tailEnd type="none" w="med" len="med"/>
                     </a:lnB>
                     <a:solidFill>
+                      <a:srgbClr val="F1F4F8"/>
+                    </a:solidFill>
+                  </a:tcPr>
+                </a:tc>
+                <a:tc>
+                  <a:txBody>
+                    <a:bodyPr/>
+                    <a:lstStyle/>
+                    <a:p>
+                      <a:pPr algn="r" indent="0" marL="0">
+                        <a:buNone/>
+                      </a:pPr>
+                      <a:r>
+                        <a:rPr lang="en-US" sz="1050" dirty="0">
+                          <a:solidFill>
+                            <a:srgbClr val="1F2937"/>
+                          </a:solidFill>
+                        </a:rPr>
+                        <a:t>16,800</a:t>
+                      </a:r>
+                      <a:endParaRPr lang="en-US" sz="1050" dirty="0"/>
+                    </a:p>
+                  </a:txBody>
+                  <a:tcPr marL="73152" marR="73152" marT="27432" marB="27432" anchor="ctr">
+                    <a:lnL w="0" cap="flat" cmpd="sng" algn="ctr">
+                      <a:noFill/>
+                    </a:lnL>
+                    <a:lnR w="0" cap="flat" cmpd="sng" algn="ctr">
+                      <a:noFill/>
+                    </a:lnR>
+                    <a:lnT w="0" cap="flat" cmpd="sng" algn="ctr">
+                      <a:noFill/>
+                    </a:lnT>
+                    <a:lnB w="9525" cap="flat" cmpd="sng" algn="ctr">
+                      <a:solidFill>
+                        <a:srgbClr val="D5DCE6"/>
+                      </a:solidFill>
+                      <a:prstDash val="solid"/>
+                      <a:round/>
+                      <a:headEnd type="none" w="med" len="med"/>
+                      <a:tailEnd type="none" w="med" len="med"/>
+                    </a:lnB>
+                    <a:solidFill>
+                      <a:srgbClr val="F1F4F8"/>
+                    </a:solidFill>
+                  </a:tcPr>
+                </a:tc>
+                <a:tc>
+                  <a:txBody>
+                    <a:bodyPr/>
+                    <a:lstStyle/>
+                    <a:p>
+                      <a:pPr algn="r" indent="0" marL="0">
+                        <a:buNone/>
+                      </a:pPr>
+                      <a:r>
+                        <a:rPr lang="en-US" sz="1050" dirty="0">
+                          <a:solidFill>
+                            <a:srgbClr val="1F2937"/>
+                          </a:solidFill>
+                        </a:rPr>
+                        <a:t>18,000</a:t>
+                      </a:r>
+                      <a:endParaRPr lang="en-US" sz="1050" dirty="0"/>
+                    </a:p>
+                  </a:txBody>
+                  <a:tcPr marL="73152" marR="73152" marT="27432" marB="27432" anchor="ctr">
+                    <a:lnL w="0" cap="flat" cmpd="sng" algn="ctr">
+                      <a:noFill/>
+                    </a:lnL>
+                    <a:lnR w="0" cap="flat" cmpd="sng" algn="ctr">
+                      <a:noFill/>
+                    </a:lnR>
+                    <a:lnT w="0" cap="flat" cmpd="sng" algn="ctr">
+                      <a:noFill/>
+                    </a:lnT>
+                    <a:lnB w="9525" cap="flat" cmpd="sng" algn="ctr">
+                      <a:solidFill>
+                        <a:srgbClr val="D5DCE6"/>
+                      </a:solidFill>
+                      <a:prstDash val="solid"/>
+                      <a:round/>
+                      <a:headEnd type="none" w="med" len="med"/>
+                      <a:tailEnd type="none" w="med" len="med"/>
+                    </a:lnB>
+                    <a:solidFill>
+                      <a:srgbClr val="F1F4F8"/>
+                    </a:solidFill>
+                  </a:tcPr>
+                </a:tc>
+                <a:tc>
+                  <a:txBody>
+                    <a:bodyPr/>
+                    <a:lstStyle/>
+                    <a:p>
+                      <a:pPr algn="r" indent="0" marL="0">
+                        <a:buNone/>
+                      </a:pPr>
+                      <a:r>
+                        <a:rPr lang="en-US" sz="1050" dirty="0">
+                          <a:solidFill>
+                            <a:srgbClr val="1F2937"/>
+                          </a:solidFill>
+                        </a:rPr>
+                        <a:t>19,290</a:t>
+                      </a:r>
+                      <a:endParaRPr lang="en-US" sz="1050" dirty="0"/>
+                    </a:p>
+                  </a:txBody>
+                  <a:tcPr marL="73152" marR="73152" marT="27432" marB="27432" anchor="ctr">
+                    <a:lnL w="0" cap="flat" cmpd="sng" algn="ctr">
+                      <a:noFill/>
+                    </a:lnL>
+                    <a:lnR w="0" cap="flat" cmpd="sng" algn="ctr">
+                      <a:noFill/>
+                    </a:lnR>
+                    <a:lnT w="0" cap="flat" cmpd="sng" algn="ctr">
+                      <a:noFill/>
+                    </a:lnT>
+                    <a:lnB w="9525" cap="flat" cmpd="sng" algn="ctr">
+                      <a:solidFill>
+                        <a:srgbClr val="D5DCE6"/>
+                      </a:solidFill>
+                      <a:prstDash val="solid"/>
+                      <a:round/>
+                      <a:headEnd type="none" w="med" len="med"/>
+                      <a:tailEnd type="none" w="med" len="med"/>
+                    </a:lnB>
+                    <a:solidFill>
+                      <a:srgbClr val="F1F4F8"/>
+                    </a:solidFill>
+                  </a:tcPr>
+                </a:tc>
+                <a:tc>
+                  <a:txBody>
+                    <a:bodyPr/>
+                    <a:lstStyle/>
+                    <a:p>
+                      <a:pPr algn="r" indent="0" marL="0">
+                        <a:buNone/>
+                      </a:pPr>
+                      <a:r>
+                        <a:rPr lang="en-US" sz="1050" dirty="0">
+                          <a:solidFill>
+                            <a:srgbClr val="1F2937"/>
+                          </a:solidFill>
+                        </a:rPr>
+                        <a:t>20,675</a:t>
+                      </a:r>
+                      <a:endParaRPr lang="en-US" sz="1050" dirty="0"/>
+                    </a:p>
+                  </a:txBody>
+                  <a:tcPr marL="73152" marR="73152" marT="27432" marB="27432" anchor="ctr">
+                    <a:lnL w="0" cap="flat" cmpd="sng" algn="ctr">
+                      <a:noFill/>
+                    </a:lnL>
+                    <a:lnR w="0" cap="flat" cmpd="sng" algn="ctr">
+                      <a:noFill/>
+                    </a:lnR>
+                    <a:lnT w="0" cap="flat" cmpd="sng" algn="ctr">
+                      <a:noFill/>
+                    </a:lnT>
+                    <a:lnB w="9525" cap="flat" cmpd="sng" algn="ctr">
+                      <a:solidFill>
+                        <a:srgbClr val="D5DCE6"/>
+                      </a:solidFill>
+                      <a:prstDash val="solid"/>
+                      <a:round/>
+                      <a:headEnd type="none" w="med" len="med"/>
+                      <a:tailEnd type="none" w="med" len="med"/>
+                    </a:lnB>
+                    <a:solidFill>
+                      <a:srgbClr val="F1F4F8"/>
+                    </a:solidFill>
+                  </a:tcPr>
+                </a:tc>
+                <a:tc>
+                  <a:txBody>
+                    <a:bodyPr/>
+                    <a:lstStyle/>
+                    <a:p>
+                      <a:pPr algn="r" indent="0" marL="0">
+                        <a:buNone/>
+                      </a:pPr>
+                      <a:r>
+                        <a:rPr lang="en-US" sz="1050" dirty="0">
+                          <a:solidFill>
+                            <a:srgbClr val="1F2937"/>
+                          </a:solidFill>
+                        </a:rPr>
+                        <a:t>22,158</a:t>
+                      </a:r>
+                      <a:endParaRPr lang="en-US" sz="1050" dirty="0"/>
+                    </a:p>
+                  </a:txBody>
+                  <a:tcPr marL="73152" marR="73152" marT="27432" marB="27432" anchor="ctr">
+                    <a:lnL w="0" cap="flat" cmpd="sng" algn="ctr">
+                      <a:noFill/>
+                    </a:lnL>
+                    <a:lnR w="0" cap="flat" cmpd="sng" algn="ctr">
+                      <a:noFill/>
+                    </a:lnR>
+                    <a:lnT w="0" cap="flat" cmpd="sng" algn="ctr">
+                      <a:noFill/>
+                    </a:lnT>
+                    <a:lnB w="9525" cap="flat" cmpd="sng" algn="ctr">
+                      <a:solidFill>
+                        <a:srgbClr val="D5DCE6"/>
+                      </a:solidFill>
+                      <a:prstDash val="solid"/>
+                      <a:round/>
+                      <a:headEnd type="none" w="med" len="med"/>
+                      <a:tailEnd type="none" w="med" len="med"/>
+                    </a:lnB>
+                    <a:solidFill>
+                      <a:srgbClr val="F1F4F8"/>
+                    </a:solidFill>
+                  </a:tcPr>
+                </a:tc>
+                <a:tc>
+                  <a:txBody>
+                    <a:bodyPr/>
+                    <a:lstStyle/>
+                    <a:p>
+                      <a:pPr algn="r" indent="0" marL="0">
+                        <a:buNone/>
+                      </a:pPr>
+                      <a:r>
+                        <a:rPr lang="en-US" sz="1050" b="1" dirty="0">
+                          <a:solidFill>
+                            <a:srgbClr val="1F2937"/>
+                          </a:solidFill>
+                        </a:rPr>
+                        <a:t>96,923</a:t>
+                      </a:r>
+                      <a:endParaRPr lang="en-US" sz="1050" dirty="0"/>
+                    </a:p>
+                  </a:txBody>
+                  <a:tcPr marL="73152" marR="73152" marT="27432" marB="27432" anchor="ctr">
+                    <a:lnL w="0" cap="flat" cmpd="sng" algn="ctr">
+                      <a:noFill/>
+                    </a:lnL>
+                    <a:lnR w="0" cap="flat" cmpd="sng" algn="ctr">
+                      <a:noFill/>
+                    </a:lnR>
+                    <a:lnT w="0" cap="flat" cmpd="sng" algn="ctr">
+                      <a:noFill/>
+                    </a:lnT>
+                    <a:lnB w="9525" cap="flat" cmpd="sng" algn="ctr">
+                      <a:solidFill>
+                        <a:srgbClr val="D5DCE6"/>
+                      </a:solidFill>
+                      <a:prstDash val="solid"/>
+                      <a:round/>
+                      <a:headEnd type="none" w="med" len="med"/>
+                      <a:tailEnd type="none" w="med" len="med"/>
+                    </a:lnB>
+                    <a:solidFill>
+                      <a:srgbClr val="F1F4F8"/>
+                    </a:solidFill>
+                  </a:tcPr>
+                </a:tc>
+              </a:tr>
+              <a:tr h="265176">
+                <a:tc>
+                  <a:txBody>
+                    <a:bodyPr/>
+                    <a:lstStyle/>
+                    <a:p>
+                      <a:pPr indent="0" marL="0">
+                        <a:buNone/>
+                      </a:pPr>
+                      <a:r>
+                        <a:rPr lang="en-US" sz="1050" b="1" dirty="0">
+                          <a:solidFill>
+                            <a:srgbClr val="1F2937"/>
+                          </a:solidFill>
+                        </a:rPr>
+                        <a:t>Subscription (Section 3.1) subtotal</a:t>
+                      </a:r>
+                      <a:endParaRPr lang="en-US" sz="1050" dirty="0"/>
+                    </a:p>
+                  </a:txBody>
+                  <a:tcPr marL="73152" marR="73152" marT="27432" marB="27432" anchor="ctr">
+                    <a:lnL w="0" cap="flat" cmpd="sng" algn="ctr">
+                      <a:noFill/>
+                    </a:lnL>
+                    <a:lnR w="0" cap="flat" cmpd="sng" algn="ctr">
+                      <a:noFill/>
+                    </a:lnR>
+                    <a:lnT w="0" cap="flat" cmpd="sng" algn="ctr">
+                      <a:noFill/>
+                    </a:lnT>
+                    <a:lnB w="9525" cap="flat" cmpd="sng" algn="ctr">
+                      <a:solidFill>
+                        <a:srgbClr val="D5DCE6"/>
+                      </a:solidFill>
+                      <a:prstDash val="solid"/>
+                      <a:round/>
+                      <a:headEnd type="none" w="med" len="med"/>
+                      <a:tailEnd type="none" w="med" len="med"/>
+                    </a:lnB>
+                    <a:solidFill>
+                      <a:srgbClr val="DDEFF1"/>
+                    </a:solidFill>
+                  </a:tcPr>
+                </a:tc>
+                <a:tc>
+                  <a:txBody>
+                    <a:bodyPr/>
+                    <a:lstStyle/>
+                    <a:p>
+                      <a:pPr algn="r" indent="0" marL="0">
+                        <a:buNone/>
+                      </a:pPr>
+                      <a:r>
+                        <a:rPr lang="en-US" sz="1050" b="1" dirty="0">
+                          <a:solidFill>
+                            <a:srgbClr val="1F2937"/>
+                          </a:solidFill>
+                        </a:rPr>
+                        <a:t>77,600</a:t>
+                      </a:r>
+                      <a:endParaRPr lang="en-US" sz="1050" dirty="0"/>
+                    </a:p>
+                  </a:txBody>
+                  <a:tcPr marL="73152" marR="73152" marT="27432" marB="27432" anchor="ctr">
+                    <a:lnL w="0" cap="flat" cmpd="sng" algn="ctr">
+                      <a:noFill/>
+                    </a:lnL>
+                    <a:lnR w="0" cap="flat" cmpd="sng" algn="ctr">
+                      <a:noFill/>
+                    </a:lnR>
+                    <a:lnT w="0" cap="flat" cmpd="sng" algn="ctr">
+                      <a:noFill/>
+                    </a:lnT>
+                    <a:lnB w="9525" cap="flat" cmpd="sng" algn="ctr">
+                      <a:solidFill>
+                        <a:srgbClr val="D5DCE6"/>
+                      </a:solidFill>
+                      <a:prstDash val="solid"/>
+                      <a:round/>
+                      <a:headEnd type="none" w="med" len="med"/>
+                      <a:tailEnd type="none" w="med" len="med"/>
+                    </a:lnB>
+                    <a:solidFill>
+                      <a:srgbClr val="DDEFF1"/>
+                    </a:solidFill>
+                  </a:tcPr>
+                </a:tc>
+                <a:tc>
+                  <a:txBody>
+                    <a:bodyPr/>
+                    <a:lstStyle/>
+                    <a:p>
+                      <a:pPr algn="r" indent="0" marL="0">
+                        <a:buNone/>
+                      </a:pPr>
+                      <a:r>
+                        <a:rPr lang="en-US" sz="1050" b="1" dirty="0">
+                          <a:solidFill>
+                            <a:srgbClr val="1F2937"/>
+                          </a:solidFill>
+                        </a:rPr>
+                        <a:t>70,640</a:t>
+                      </a:r>
+                      <a:endParaRPr lang="en-US" sz="1050" dirty="0"/>
+                    </a:p>
+                  </a:txBody>
+                  <a:tcPr marL="73152" marR="73152" marT="27432" marB="27432" anchor="ctr">
+                    <a:lnL w="0" cap="flat" cmpd="sng" algn="ctr">
+                      <a:noFill/>
+                    </a:lnL>
+                    <a:lnR w="0" cap="flat" cmpd="sng" algn="ctr">
+                      <a:noFill/>
+                    </a:lnR>
+                    <a:lnT w="0" cap="flat" cmpd="sng" algn="ctr">
+                      <a:noFill/>
+                    </a:lnT>
+                    <a:lnB w="9525" cap="flat" cmpd="sng" algn="ctr">
+                      <a:solidFill>
+                        <a:srgbClr val="D5DCE6"/>
+                      </a:solidFill>
+                      <a:prstDash val="solid"/>
+                      <a:round/>
+                      <a:headEnd type="none" w="med" len="med"/>
+                      <a:tailEnd type="none" w="med" len="med"/>
+                    </a:lnB>
+                    <a:solidFill>
+                      <a:srgbClr val="DDEFF1"/>
+                    </a:solidFill>
+                  </a:tcPr>
+                </a:tc>
+                <a:tc>
+                  <a:txBody>
+                    <a:bodyPr/>
+                    <a:lstStyle/>
+                    <a:p>
+                      <a:pPr algn="r" indent="0" marL="0">
+                        <a:buNone/>
+                      </a:pPr>
+                      <a:r>
+                        <a:rPr lang="en-US" sz="1050" b="1" dirty="0">
+                          <a:solidFill>
+                            <a:srgbClr val="1F2937"/>
+                          </a:solidFill>
+                        </a:rPr>
+                        <a:t>74,562</a:t>
+                      </a:r>
+                      <a:endParaRPr lang="en-US" sz="1050" dirty="0"/>
+                    </a:p>
+                  </a:txBody>
+                  <a:tcPr marL="73152" marR="73152" marT="27432" marB="27432" anchor="ctr">
+                    <a:lnL w="0" cap="flat" cmpd="sng" algn="ctr">
+                      <a:noFill/>
+                    </a:lnL>
+                    <a:lnR w="0" cap="flat" cmpd="sng" algn="ctr">
+                      <a:noFill/>
+                    </a:lnR>
+                    <a:lnT w="0" cap="flat" cmpd="sng" algn="ctr">
+                      <a:noFill/>
+                    </a:lnT>
+                    <a:lnB w="9525" cap="flat" cmpd="sng" algn="ctr">
+                      <a:solidFill>
+                        <a:srgbClr val="D5DCE6"/>
+                      </a:solidFill>
+                      <a:prstDash val="solid"/>
+                      <a:round/>
+                      <a:headEnd type="none" w="med" len="med"/>
+                      <a:tailEnd type="none" w="med" len="med"/>
+                    </a:lnB>
+                    <a:solidFill>
+                      <a:srgbClr val="DDEFF1"/>
+                    </a:solidFill>
+                  </a:tcPr>
+                </a:tc>
+                <a:tc>
+                  <a:txBody>
+                    <a:bodyPr/>
+                    <a:lstStyle/>
+                    <a:p>
+                      <a:pPr algn="r" indent="0" marL="0">
+                        <a:buNone/>
+                      </a:pPr>
+                      <a:r>
+                        <a:rPr lang="en-US" sz="1050" b="1" dirty="0">
+                          <a:solidFill>
+                            <a:srgbClr val="1F2937"/>
+                          </a:solidFill>
+                        </a:rPr>
+                        <a:t>81,797</a:t>
+                      </a:r>
+                      <a:endParaRPr lang="en-US" sz="1050" dirty="0"/>
+                    </a:p>
+                  </a:txBody>
+                  <a:tcPr marL="73152" marR="73152" marT="27432" marB="27432" anchor="ctr">
+                    <a:lnL w="0" cap="flat" cmpd="sng" algn="ctr">
+                      <a:noFill/>
+                    </a:lnL>
+                    <a:lnR w="0" cap="flat" cmpd="sng" algn="ctr">
+                      <a:noFill/>
+                    </a:lnR>
+                    <a:lnT w="0" cap="flat" cmpd="sng" algn="ctr">
+                      <a:noFill/>
+                    </a:lnT>
+                    <a:lnB w="9525" cap="flat" cmpd="sng" algn="ctr">
+                      <a:solidFill>
+                        <a:srgbClr val="D5DCE6"/>
+                      </a:solidFill>
+                      <a:prstDash val="solid"/>
+                      <a:round/>
+                      <a:headEnd type="none" w="med" len="med"/>
+                      <a:tailEnd type="none" w="med" len="med"/>
+                    </a:lnB>
+                    <a:solidFill>
+                      <a:srgbClr val="DDEFF1"/>
+                    </a:solidFill>
+                  </a:tcPr>
+                </a:tc>
+                <a:tc>
+                  <a:txBody>
+                    <a:bodyPr/>
+                    <a:lstStyle/>
+                    <a:p>
+                      <a:pPr algn="r" indent="0" marL="0">
+                        <a:buNone/>
+                      </a:pPr>
+                      <a:r>
+                        <a:rPr lang="en-US" sz="1050" b="1" dirty="0">
+                          <a:solidFill>
+                            <a:srgbClr val="1F2937"/>
+                          </a:solidFill>
+                        </a:rPr>
+                        <a:t>83,096</a:t>
+                      </a:r>
+                      <a:endParaRPr lang="en-US" sz="1050" dirty="0"/>
+                    </a:p>
+                  </a:txBody>
+                  <a:tcPr marL="73152" marR="73152" marT="27432" marB="27432" anchor="ctr">
+                    <a:lnL w="0" cap="flat" cmpd="sng" algn="ctr">
+                      <a:noFill/>
+                    </a:lnL>
+                    <a:lnR w="0" cap="flat" cmpd="sng" algn="ctr">
+                      <a:noFill/>
+                    </a:lnR>
+                    <a:lnT w="0" cap="flat" cmpd="sng" algn="ctr">
+                      <a:noFill/>
+                    </a:lnT>
+                    <a:lnB w="9525" cap="flat" cmpd="sng" algn="ctr">
+                      <a:solidFill>
+                        <a:srgbClr val="D5DCE6"/>
+                      </a:solidFill>
+                      <a:prstDash val="solid"/>
+                      <a:round/>
+                      <a:headEnd type="none" w="med" len="med"/>
+                      <a:tailEnd type="none" w="med" len="med"/>
+                    </a:lnB>
+                    <a:solidFill>
+                      <a:srgbClr val="DDEFF1"/>
+                    </a:solidFill>
+                  </a:tcPr>
+                </a:tc>
+                <a:tc>
+                  <a:txBody>
+                    <a:bodyPr/>
+                    <a:lstStyle/>
+                    <a:p>
+                      <a:pPr algn="r" indent="0" marL="0">
+                        <a:buNone/>
+                      </a:pPr>
+                      <a:r>
+                        <a:rPr lang="en-US" sz="1050" b="1" dirty="0">
+                          <a:solidFill>
+                            <a:srgbClr val="1F2937"/>
+                          </a:solidFill>
+                        </a:rPr>
+                        <a:t>387,695</a:t>
+                      </a:r>
+                      <a:endParaRPr lang="en-US" sz="1050" dirty="0"/>
+                    </a:p>
+                  </a:txBody>
+                  <a:tcPr marL="73152" marR="73152" marT="27432" marB="27432" anchor="ctr">
+                    <a:lnL w="0" cap="flat" cmpd="sng" algn="ctr">
+                      <a:noFill/>
+                    </a:lnL>
+                    <a:lnR w="0" cap="flat" cmpd="sng" algn="ctr">
+                      <a:noFill/>
+                    </a:lnR>
+                    <a:lnT w="0" cap="flat" cmpd="sng" algn="ctr">
+                      <a:noFill/>
+                    </a:lnT>
+                    <a:lnB w="9525" cap="flat" cmpd="sng" algn="ctr">
+                      <a:solidFill>
+                        <a:srgbClr val="D5DCE6"/>
+                      </a:solidFill>
+                      <a:prstDash val="solid"/>
+                      <a:round/>
+                      <a:headEnd type="none" w="med" len="med"/>
+                      <a:tailEnd type="none" w="med" len="med"/>
+                    </a:lnB>
+                    <a:solidFill>
+                      <a:srgbClr val="DDEFF1"/>
+                    </a:solidFill>
+                  </a:tcPr>
+                </a:tc>
+              </a:tr>
+              <a:tr h="265176">
+                <a:tc>
+                  <a:txBody>
+                    <a:bodyPr/>
+                    <a:lstStyle/>
+                    <a:p>
+                      <a:pPr indent="0" marL="0">
+                        <a:buNone/>
+                      </a:pPr>
+                      <a:r>
+                        <a:rPr lang="en-US" sz="1050" dirty="0">
+                          <a:solidFill>
+                            <a:srgbClr val="1F2937"/>
+                          </a:solidFill>
+                        </a:rPr>
+                        <a:t>Preventive maintenance labour (Item 6)</a:t>
+                      </a:r>
+                      <a:endParaRPr lang="en-US" sz="1050" dirty="0"/>
+                    </a:p>
+                  </a:txBody>
+                  <a:tcPr marL="73152" marR="73152" marT="27432" marB="27432" anchor="ctr">
+                    <a:lnL w="0" cap="flat" cmpd="sng" algn="ctr">
+                      <a:noFill/>
+                    </a:lnL>
+                    <a:lnR w="0" cap="flat" cmpd="sng" algn="ctr">
+                      <a:noFill/>
+                    </a:lnR>
+                    <a:lnT w="0" cap="flat" cmpd="sng" algn="ctr">
+                      <a:noFill/>
+                    </a:lnT>
+                    <a:lnB w="9525" cap="flat" cmpd="sng" algn="ctr">
+                      <a:solidFill>
+                        <a:srgbClr val="D5DCE6"/>
+                      </a:solidFill>
+                      <a:prstDash val="solid"/>
+                      <a:round/>
+                      <a:headEnd type="none" w="med" len="med"/>
+                      <a:tailEnd type="none" w="med" len="med"/>
+                    </a:lnB>
+                    <a:solidFill>
                       <a:srgbClr val="FFFFFF"/>
                     </a:solidFill>
                   </a:tcPr>
@@ -3311,7 +4221,7 @@
                             <a:srgbClr val="1F2937"/>
                           </a:solidFill>
                         </a:rPr>
-                        <a:t>16,800</a:t>
+                        <a:t>19,200</a:t>
                       </a:r>
                       <a:endParaRPr lang="en-US" sz="1050" dirty="0"/>
                     </a:p>
@@ -3354,7 +4264,7 @@
                             <a:srgbClr val="1F2937"/>
                           </a:solidFill>
                         </a:rPr>
-                        <a:t>18,000</a:t>
+                        <a:t>19,800</a:t>
                       </a:r>
                       <a:endParaRPr lang="en-US" sz="1050" dirty="0"/>
                     </a:p>
@@ -3397,7 +4307,7 @@
                             <a:srgbClr val="1F2937"/>
                           </a:solidFill>
                         </a:rPr>
-                        <a:t>19,290</a:t>
+                        <a:t>20,400</a:t>
                       </a:r>
                       <a:endParaRPr lang="en-US" sz="1050" dirty="0"/>
                     </a:p>
@@ -3440,7 +4350,7 @@
                             <a:srgbClr val="1F2937"/>
                           </a:solidFill>
                         </a:rPr>
-                        <a:t>20,675</a:t>
+                        <a:t>21,000</a:t>
                       </a:r>
                       <a:endParaRPr lang="en-US" sz="1050" dirty="0"/>
                     </a:p>
@@ -3483,7 +4393,7 @@
                             <a:srgbClr val="1F2937"/>
                           </a:solidFill>
                         </a:rPr>
-                        <a:t>22,158</a:t>
+                        <a:t>21,600</a:t>
                       </a:r>
                       <a:endParaRPr lang="en-US" sz="1050" dirty="0"/>
                     </a:p>
@@ -3526,7 +4436,7 @@
                             <a:srgbClr val="1F2937"/>
                           </a:solidFill>
                         </a:rPr>
-                        <a:t>96,923</a:t>
+                        <a:t>102,000</a:t>
                       </a:r>
                       <a:endParaRPr lang="en-US" sz="1050" dirty="0"/>
                     </a:p>
@@ -3556,7 +4466,7 @@
                   </a:tcPr>
                 </a:tc>
               </a:tr>
-              <a:tr h="283464">
+              <a:tr h="265176">
                 <a:tc>
                   <a:txBody>
                     <a:bodyPr/>
@@ -3568,10 +4478,616 @@
                       <a:r>
                         <a:rPr lang="en-US" sz="1050" b="1" dirty="0">
                           <a:solidFill>
-                            <a:srgbClr val="1F2937"/>
-                          </a:solidFill>
-                        </a:rPr>
-                        <a:t>Subscription (Section 3.1) subtotal</a:t>
+                            <a:srgbClr val="FFFFFF"/>
+                          </a:solidFill>
+                        </a:rPr>
+                        <a:t>Total annual operating cost</a:t>
+                      </a:r>
+                      <a:endParaRPr lang="en-US" sz="1050" dirty="0"/>
+                    </a:p>
+                  </a:txBody>
+                  <a:tcPr marL="73152" marR="73152" marT="27432" marB="27432" anchor="ctr">
+                    <a:lnL w="0" cap="flat" cmpd="sng" algn="ctr">
+                      <a:noFill/>
+                    </a:lnL>
+                    <a:lnR w="0" cap="flat" cmpd="sng" algn="ctr">
+                      <a:noFill/>
+                    </a:lnR>
+                    <a:lnT w="0" cap="flat" cmpd="sng" algn="ctr">
+                      <a:noFill/>
+                    </a:lnT>
+                    <a:lnB w="9525" cap="flat" cmpd="sng" algn="ctr">
+                      <a:solidFill>
+                        <a:srgbClr val="D5DCE6"/>
+                      </a:solidFill>
+                      <a:prstDash val="solid"/>
+                      <a:round/>
+                      <a:headEnd type="none" w="med" len="med"/>
+                      <a:tailEnd type="none" w="med" len="med"/>
+                    </a:lnB>
+                    <a:solidFill>
+                      <a:srgbClr val="0B2A4A"/>
+                    </a:solidFill>
+                  </a:tcPr>
+                </a:tc>
+                <a:tc>
+                  <a:txBody>
+                    <a:bodyPr/>
+                    <a:lstStyle/>
+                    <a:p>
+                      <a:pPr algn="r" indent="0" marL="0">
+                        <a:buNone/>
+                      </a:pPr>
+                      <a:r>
+                        <a:rPr lang="en-US" sz="1050" b="1" dirty="0">
+                          <a:solidFill>
+                            <a:srgbClr val="FFFFFF"/>
+                          </a:solidFill>
+                        </a:rPr>
+                        <a:t>96,800</a:t>
+                      </a:r>
+                      <a:endParaRPr lang="en-US" sz="1050" dirty="0"/>
+                    </a:p>
+                  </a:txBody>
+                  <a:tcPr marL="73152" marR="73152" marT="27432" marB="27432" anchor="ctr">
+                    <a:lnL w="0" cap="flat" cmpd="sng" algn="ctr">
+                      <a:noFill/>
+                    </a:lnL>
+                    <a:lnR w="0" cap="flat" cmpd="sng" algn="ctr">
+                      <a:noFill/>
+                    </a:lnR>
+                    <a:lnT w="0" cap="flat" cmpd="sng" algn="ctr">
+                      <a:noFill/>
+                    </a:lnT>
+                    <a:lnB w="9525" cap="flat" cmpd="sng" algn="ctr">
+                      <a:solidFill>
+                        <a:srgbClr val="D5DCE6"/>
+                      </a:solidFill>
+                      <a:prstDash val="solid"/>
+                      <a:round/>
+                      <a:headEnd type="none" w="med" len="med"/>
+                      <a:tailEnd type="none" w="med" len="med"/>
+                    </a:lnB>
+                    <a:solidFill>
+                      <a:srgbClr val="0B2A4A"/>
+                    </a:solidFill>
+                  </a:tcPr>
+                </a:tc>
+                <a:tc>
+                  <a:txBody>
+                    <a:bodyPr/>
+                    <a:lstStyle/>
+                    <a:p>
+                      <a:pPr algn="r" indent="0" marL="0">
+                        <a:buNone/>
+                      </a:pPr>
+                      <a:r>
+                        <a:rPr lang="en-US" sz="1050" b="1" dirty="0">
+                          <a:solidFill>
+                            <a:srgbClr val="FFFFFF"/>
+                          </a:solidFill>
+                        </a:rPr>
+                        <a:t>90,440</a:t>
+                      </a:r>
+                      <a:endParaRPr lang="en-US" sz="1050" dirty="0"/>
+                    </a:p>
+                  </a:txBody>
+                  <a:tcPr marL="73152" marR="73152" marT="27432" marB="27432" anchor="ctr">
+                    <a:lnL w="0" cap="flat" cmpd="sng" algn="ctr">
+                      <a:noFill/>
+                    </a:lnL>
+                    <a:lnR w="0" cap="flat" cmpd="sng" algn="ctr">
+                      <a:noFill/>
+                    </a:lnR>
+                    <a:lnT w="0" cap="flat" cmpd="sng" algn="ctr">
+                      <a:noFill/>
+                    </a:lnT>
+                    <a:lnB w="9525" cap="flat" cmpd="sng" algn="ctr">
+                      <a:solidFill>
+                        <a:srgbClr val="D5DCE6"/>
+                      </a:solidFill>
+                      <a:prstDash val="solid"/>
+                      <a:round/>
+                      <a:headEnd type="none" w="med" len="med"/>
+                      <a:tailEnd type="none" w="med" len="med"/>
+                    </a:lnB>
+                    <a:solidFill>
+                      <a:srgbClr val="0B2A4A"/>
+                    </a:solidFill>
+                  </a:tcPr>
+                </a:tc>
+                <a:tc>
+                  <a:txBody>
+                    <a:bodyPr/>
+                    <a:lstStyle/>
+                    <a:p>
+                      <a:pPr algn="r" indent="0" marL="0">
+                        <a:buNone/>
+                      </a:pPr>
+                      <a:r>
+                        <a:rPr lang="en-US" sz="1050" b="1" dirty="0">
+                          <a:solidFill>
+                            <a:srgbClr val="FFFFFF"/>
+                          </a:solidFill>
+                        </a:rPr>
+                        <a:t>94,962</a:t>
+                      </a:r>
+                      <a:endParaRPr lang="en-US" sz="1050" dirty="0"/>
+                    </a:p>
+                  </a:txBody>
+                  <a:tcPr marL="73152" marR="73152" marT="27432" marB="27432" anchor="ctr">
+                    <a:lnL w="0" cap="flat" cmpd="sng" algn="ctr">
+                      <a:noFill/>
+                    </a:lnL>
+                    <a:lnR w="0" cap="flat" cmpd="sng" algn="ctr">
+                      <a:noFill/>
+                    </a:lnR>
+                    <a:lnT w="0" cap="flat" cmpd="sng" algn="ctr">
+                      <a:noFill/>
+                    </a:lnT>
+                    <a:lnB w="9525" cap="flat" cmpd="sng" algn="ctr">
+                      <a:solidFill>
+                        <a:srgbClr val="D5DCE6"/>
+                      </a:solidFill>
+                      <a:prstDash val="solid"/>
+                      <a:round/>
+                      <a:headEnd type="none" w="med" len="med"/>
+                      <a:tailEnd type="none" w="med" len="med"/>
+                    </a:lnB>
+                    <a:solidFill>
+                      <a:srgbClr val="0B2A4A"/>
+                    </a:solidFill>
+                  </a:tcPr>
+                </a:tc>
+                <a:tc>
+                  <a:txBody>
+                    <a:bodyPr/>
+                    <a:lstStyle/>
+                    <a:p>
+                      <a:pPr algn="r" indent="0" marL="0">
+                        <a:buNone/>
+                      </a:pPr>
+                      <a:r>
+                        <a:rPr lang="en-US" sz="1050" b="1" dirty="0">
+                          <a:solidFill>
+                            <a:srgbClr val="FFFFFF"/>
+                          </a:solidFill>
+                        </a:rPr>
+                        <a:t>102,797</a:t>
+                      </a:r>
+                      <a:endParaRPr lang="en-US" sz="1050" dirty="0"/>
+                    </a:p>
+                  </a:txBody>
+                  <a:tcPr marL="73152" marR="73152" marT="27432" marB="27432" anchor="ctr">
+                    <a:lnL w="0" cap="flat" cmpd="sng" algn="ctr">
+                      <a:noFill/>
+                    </a:lnL>
+                    <a:lnR w="0" cap="flat" cmpd="sng" algn="ctr">
+                      <a:noFill/>
+                    </a:lnR>
+                    <a:lnT w="0" cap="flat" cmpd="sng" algn="ctr">
+                      <a:noFill/>
+                    </a:lnT>
+                    <a:lnB w="9525" cap="flat" cmpd="sng" algn="ctr">
+                      <a:solidFill>
+                        <a:srgbClr val="D5DCE6"/>
+                      </a:solidFill>
+                      <a:prstDash val="solid"/>
+                      <a:round/>
+                      <a:headEnd type="none" w="med" len="med"/>
+                      <a:tailEnd type="none" w="med" len="med"/>
+                    </a:lnB>
+                    <a:solidFill>
+                      <a:srgbClr val="0B2A4A"/>
+                    </a:solidFill>
+                  </a:tcPr>
+                </a:tc>
+                <a:tc>
+                  <a:txBody>
+                    <a:bodyPr/>
+                    <a:lstStyle/>
+                    <a:p>
+                      <a:pPr algn="r" indent="0" marL="0">
+                        <a:buNone/>
+                      </a:pPr>
+                      <a:r>
+                        <a:rPr lang="en-US" sz="1050" b="1" dirty="0">
+                          <a:solidFill>
+                            <a:srgbClr val="FFFFFF"/>
+                          </a:solidFill>
+                        </a:rPr>
+                        <a:t>104,696</a:t>
+                      </a:r>
+                      <a:endParaRPr lang="en-US" sz="1050" dirty="0"/>
+                    </a:p>
+                  </a:txBody>
+                  <a:tcPr marL="73152" marR="73152" marT="27432" marB="27432" anchor="ctr">
+                    <a:lnL w="0" cap="flat" cmpd="sng" algn="ctr">
+                      <a:noFill/>
+                    </a:lnL>
+                    <a:lnR w="0" cap="flat" cmpd="sng" algn="ctr">
+                      <a:noFill/>
+                    </a:lnR>
+                    <a:lnT w="0" cap="flat" cmpd="sng" algn="ctr">
+                      <a:noFill/>
+                    </a:lnT>
+                    <a:lnB w="9525" cap="flat" cmpd="sng" algn="ctr">
+                      <a:solidFill>
+                        <a:srgbClr val="D5DCE6"/>
+                      </a:solidFill>
+                      <a:prstDash val="solid"/>
+                      <a:round/>
+                      <a:headEnd type="none" w="med" len="med"/>
+                      <a:tailEnd type="none" w="med" len="med"/>
+                    </a:lnB>
+                    <a:solidFill>
+                      <a:srgbClr val="0B2A4A"/>
+                    </a:solidFill>
+                  </a:tcPr>
+                </a:tc>
+                <a:tc>
+                  <a:txBody>
+                    <a:bodyPr/>
+                    <a:lstStyle/>
+                    <a:p>
+                      <a:pPr algn="r" indent="0" marL="0">
+                        <a:buNone/>
+                      </a:pPr>
+                      <a:r>
+                        <a:rPr lang="en-US" sz="1050" b="1" dirty="0">
+                          <a:solidFill>
+                            <a:srgbClr val="FFFFFF"/>
+                          </a:solidFill>
+                        </a:rPr>
+                        <a:t>489,695</a:t>
+                      </a:r>
+                      <a:endParaRPr lang="en-US" sz="1050" dirty="0"/>
+                    </a:p>
+                  </a:txBody>
+                  <a:tcPr marL="73152" marR="73152" marT="27432" marB="27432" anchor="ctr">
+                    <a:lnL w="0" cap="flat" cmpd="sng" algn="ctr">
+                      <a:noFill/>
+                    </a:lnL>
+                    <a:lnR w="0" cap="flat" cmpd="sng" algn="ctr">
+                      <a:noFill/>
+                    </a:lnR>
+                    <a:lnT w="0" cap="flat" cmpd="sng" algn="ctr">
+                      <a:noFill/>
+                    </a:lnT>
+                    <a:lnB w="9525" cap="flat" cmpd="sng" algn="ctr">
+                      <a:solidFill>
+                        <a:srgbClr val="D5DCE6"/>
+                      </a:solidFill>
+                      <a:prstDash val="solid"/>
+                      <a:round/>
+                      <a:headEnd type="none" w="med" len="med"/>
+                      <a:tailEnd type="none" w="med" len="med"/>
+                    </a:lnB>
+                    <a:solidFill>
+                      <a:srgbClr val="0B2A4A"/>
+                    </a:solidFill>
+                  </a:tcPr>
+                </a:tc>
+              </a:tr>
+              <a:tr h="265176">
+                <a:tc>
+                  <a:txBody>
+                    <a:bodyPr/>
+                    <a:lstStyle/>
+                    <a:p>
+                      <a:pPr indent="0" marL="0">
+                        <a:buNone/>
+                      </a:pPr>
+                      <a:r>
+                        <a:rPr lang="en-US" sz="1050" i="1" dirty="0">
+                          <a:solidFill>
+                            <a:srgbClr val="7A4F00"/>
+                          </a:solidFill>
+                        </a:rPr>
+                        <a:t>Initial set-up (one-off) – to confirm</a:t>
+                      </a:r>
+                      <a:endParaRPr lang="en-US" sz="1050" dirty="0"/>
+                    </a:p>
+                  </a:txBody>
+                  <a:tcPr marL="73152" marR="73152" marT="27432" marB="27432" anchor="ctr">
+                    <a:lnL w="0" cap="flat" cmpd="sng" algn="ctr">
+                      <a:noFill/>
+                    </a:lnL>
+                    <a:lnR w="0" cap="flat" cmpd="sng" algn="ctr">
+                      <a:noFill/>
+                    </a:lnR>
+                    <a:lnT w="0" cap="flat" cmpd="sng" algn="ctr">
+                      <a:noFill/>
+                    </a:lnT>
+                    <a:lnB w="9525" cap="flat" cmpd="sng" algn="ctr">
+                      <a:solidFill>
+                        <a:srgbClr val="D5DCE6"/>
+                      </a:solidFill>
+                      <a:prstDash val="solid"/>
+                      <a:round/>
+                      <a:headEnd type="none" w="med" len="med"/>
+                      <a:tailEnd type="none" w="med" len="med"/>
+                    </a:lnB>
+                    <a:solidFill>
+                      <a:srgbClr val="FFF4D6"/>
+                    </a:solidFill>
+                  </a:tcPr>
+                </a:tc>
+                <a:tc>
+                  <a:txBody>
+                    <a:bodyPr/>
+                    <a:lstStyle/>
+                    <a:p>
+                      <a:pPr algn="r" indent="0" marL="0">
+                        <a:buNone/>
+                      </a:pPr>
+                      <a:r>
+                        <a:rPr lang="en-US" sz="1050" i="1" dirty="0">
+                          <a:solidFill>
+                            <a:srgbClr val="7A4F00"/>
+                          </a:solidFill>
+                        </a:rPr>
+                        <a:t>14,286</a:t>
+                      </a:r>
+                      <a:endParaRPr lang="en-US" sz="1050" dirty="0"/>
+                    </a:p>
+                  </a:txBody>
+                  <a:tcPr marL="73152" marR="73152" marT="27432" marB="27432" anchor="ctr">
+                    <a:lnL w="0" cap="flat" cmpd="sng" algn="ctr">
+                      <a:noFill/>
+                    </a:lnL>
+                    <a:lnR w="0" cap="flat" cmpd="sng" algn="ctr">
+                      <a:noFill/>
+                    </a:lnR>
+                    <a:lnT w="0" cap="flat" cmpd="sng" algn="ctr">
+                      <a:noFill/>
+                    </a:lnT>
+                    <a:lnB w="9525" cap="flat" cmpd="sng" algn="ctr">
+                      <a:solidFill>
+                        <a:srgbClr val="D5DCE6"/>
+                      </a:solidFill>
+                      <a:prstDash val="solid"/>
+                      <a:round/>
+                      <a:headEnd type="none" w="med" len="med"/>
+                      <a:tailEnd type="none" w="med" len="med"/>
+                    </a:lnB>
+                    <a:solidFill>
+                      <a:srgbClr val="FFF4D6"/>
+                    </a:solidFill>
+                  </a:tcPr>
+                </a:tc>
+                <a:tc>
+                  <a:txBody>
+                    <a:bodyPr/>
+                    <a:lstStyle/>
+                    <a:p>
+                      <a:pPr algn="r" indent="0" marL="0">
+                        <a:buNone/>
+                      </a:pPr>
+                      <a:r>
+                        <a:rPr lang="en-US" sz="1050" dirty="0">
+                          <a:solidFill>
+                            <a:srgbClr val="7A4F00"/>
+                          </a:solidFill>
+                        </a:rPr>
+                        <a:t>–</a:t>
+                      </a:r>
+                      <a:endParaRPr lang="en-US" sz="1050" dirty="0"/>
+                    </a:p>
+                  </a:txBody>
+                  <a:tcPr marL="73152" marR="73152" marT="27432" marB="27432" anchor="ctr">
+                    <a:lnL w="0" cap="flat" cmpd="sng" algn="ctr">
+                      <a:noFill/>
+                    </a:lnL>
+                    <a:lnR w="0" cap="flat" cmpd="sng" algn="ctr">
+                      <a:noFill/>
+                    </a:lnR>
+                    <a:lnT w="0" cap="flat" cmpd="sng" algn="ctr">
+                      <a:noFill/>
+                    </a:lnT>
+                    <a:lnB w="9525" cap="flat" cmpd="sng" algn="ctr">
+                      <a:solidFill>
+                        <a:srgbClr val="D5DCE6"/>
+                      </a:solidFill>
+                      <a:prstDash val="solid"/>
+                      <a:round/>
+                      <a:headEnd type="none" w="med" len="med"/>
+                      <a:tailEnd type="none" w="med" len="med"/>
+                    </a:lnB>
+                    <a:solidFill>
+                      <a:srgbClr val="FFF4D6"/>
+                    </a:solidFill>
+                  </a:tcPr>
+                </a:tc>
+                <a:tc>
+                  <a:txBody>
+                    <a:bodyPr/>
+                    <a:lstStyle/>
+                    <a:p>
+                      <a:pPr algn="r" indent="0" marL="0">
+                        <a:buNone/>
+                      </a:pPr>
+                      <a:r>
+                        <a:rPr lang="en-US" sz="1050" dirty="0">
+                          <a:solidFill>
+                            <a:srgbClr val="7A4F00"/>
+                          </a:solidFill>
+                        </a:rPr>
+                        <a:t>–</a:t>
+                      </a:r>
+                      <a:endParaRPr lang="en-US" sz="1050" dirty="0"/>
+                    </a:p>
+                  </a:txBody>
+                  <a:tcPr marL="73152" marR="73152" marT="27432" marB="27432" anchor="ctr">
+                    <a:lnL w="0" cap="flat" cmpd="sng" algn="ctr">
+                      <a:noFill/>
+                    </a:lnL>
+                    <a:lnR w="0" cap="flat" cmpd="sng" algn="ctr">
+                      <a:noFill/>
+                    </a:lnR>
+                    <a:lnT w="0" cap="flat" cmpd="sng" algn="ctr">
+                      <a:noFill/>
+                    </a:lnT>
+                    <a:lnB w="9525" cap="flat" cmpd="sng" algn="ctr">
+                      <a:solidFill>
+                        <a:srgbClr val="D5DCE6"/>
+                      </a:solidFill>
+                      <a:prstDash val="solid"/>
+                      <a:round/>
+                      <a:headEnd type="none" w="med" len="med"/>
+                      <a:tailEnd type="none" w="med" len="med"/>
+                    </a:lnB>
+                    <a:solidFill>
+                      <a:srgbClr val="FFF4D6"/>
+                    </a:solidFill>
+                  </a:tcPr>
+                </a:tc>
+                <a:tc>
+                  <a:txBody>
+                    <a:bodyPr/>
+                    <a:lstStyle/>
+                    <a:p>
+                      <a:pPr algn="r" indent="0" marL="0">
+                        <a:buNone/>
+                      </a:pPr>
+                      <a:r>
+                        <a:rPr lang="en-US" sz="1050" dirty="0">
+                          <a:solidFill>
+                            <a:srgbClr val="7A4F00"/>
+                          </a:solidFill>
+                        </a:rPr>
+                        <a:t>–</a:t>
+                      </a:r>
+                      <a:endParaRPr lang="en-US" sz="1050" dirty="0"/>
+                    </a:p>
+                  </a:txBody>
+                  <a:tcPr marL="73152" marR="73152" marT="27432" marB="27432" anchor="ctr">
+                    <a:lnL w="0" cap="flat" cmpd="sng" algn="ctr">
+                      <a:noFill/>
+                    </a:lnL>
+                    <a:lnR w="0" cap="flat" cmpd="sng" algn="ctr">
+                      <a:noFill/>
+                    </a:lnR>
+                    <a:lnT w="0" cap="flat" cmpd="sng" algn="ctr">
+                      <a:noFill/>
+                    </a:lnT>
+                    <a:lnB w="9525" cap="flat" cmpd="sng" algn="ctr">
+                      <a:solidFill>
+                        <a:srgbClr val="D5DCE6"/>
+                      </a:solidFill>
+                      <a:prstDash val="solid"/>
+                      <a:round/>
+                      <a:headEnd type="none" w="med" len="med"/>
+                      <a:tailEnd type="none" w="med" len="med"/>
+                    </a:lnB>
+                    <a:solidFill>
+                      <a:srgbClr val="FFF4D6"/>
+                    </a:solidFill>
+                  </a:tcPr>
+                </a:tc>
+                <a:tc>
+                  <a:txBody>
+                    <a:bodyPr/>
+                    <a:lstStyle/>
+                    <a:p>
+                      <a:pPr algn="r" indent="0" marL="0">
+                        <a:buNone/>
+                      </a:pPr>
+                      <a:r>
+                        <a:rPr lang="en-US" sz="1050" dirty="0">
+                          <a:solidFill>
+                            <a:srgbClr val="7A4F00"/>
+                          </a:solidFill>
+                        </a:rPr>
+                        <a:t>–</a:t>
+                      </a:r>
+                      <a:endParaRPr lang="en-US" sz="1050" dirty="0"/>
+                    </a:p>
+                  </a:txBody>
+                  <a:tcPr marL="73152" marR="73152" marT="27432" marB="27432" anchor="ctr">
+                    <a:lnL w="0" cap="flat" cmpd="sng" algn="ctr">
+                      <a:noFill/>
+                    </a:lnL>
+                    <a:lnR w="0" cap="flat" cmpd="sng" algn="ctr">
+                      <a:noFill/>
+                    </a:lnR>
+                    <a:lnT w="0" cap="flat" cmpd="sng" algn="ctr">
+                      <a:noFill/>
+                    </a:lnT>
+                    <a:lnB w="9525" cap="flat" cmpd="sng" algn="ctr">
+                      <a:solidFill>
+                        <a:srgbClr val="D5DCE6"/>
+                      </a:solidFill>
+                      <a:prstDash val="solid"/>
+                      <a:round/>
+                      <a:headEnd type="none" w="med" len="med"/>
+                      <a:tailEnd type="none" w="med" len="med"/>
+                    </a:lnB>
+                    <a:solidFill>
+                      <a:srgbClr val="FFF4D6"/>
+                    </a:solidFill>
+                  </a:tcPr>
+                </a:tc>
+                <a:tc>
+                  <a:txBody>
+                    <a:bodyPr/>
+                    <a:lstStyle/>
+                    <a:p>
+                      <a:pPr algn="r" indent="0" marL="0">
+                        <a:buNone/>
+                      </a:pPr>
+                      <a:r>
+                        <a:rPr lang="en-US" sz="1050" b="1" i="1" dirty="0">
+                          <a:solidFill>
+                            <a:srgbClr val="7A4F00"/>
+                          </a:solidFill>
+                        </a:rPr>
+                        <a:t>14,286</a:t>
+                      </a:r>
+                      <a:endParaRPr lang="en-US" sz="1050" dirty="0"/>
+                    </a:p>
+                  </a:txBody>
+                  <a:tcPr marL="73152" marR="73152" marT="27432" marB="27432" anchor="ctr">
+                    <a:lnL w="0" cap="flat" cmpd="sng" algn="ctr">
+                      <a:noFill/>
+                    </a:lnL>
+                    <a:lnR w="0" cap="flat" cmpd="sng" algn="ctr">
+                      <a:noFill/>
+                    </a:lnR>
+                    <a:lnT w="0" cap="flat" cmpd="sng" algn="ctr">
+                      <a:noFill/>
+                    </a:lnT>
+                    <a:lnB w="9525" cap="flat" cmpd="sng" algn="ctr">
+                      <a:solidFill>
+                        <a:srgbClr val="D5DCE6"/>
+                      </a:solidFill>
+                      <a:prstDash val="solid"/>
+                      <a:round/>
+                      <a:headEnd type="none" w="med" len="med"/>
+                      <a:tailEnd type="none" w="med" len="med"/>
+                    </a:lnB>
+                    <a:solidFill>
+                      <a:srgbClr val="FFF4D6"/>
+                    </a:solidFill>
+                  </a:tcPr>
+                </a:tc>
+              </a:tr>
+              <a:tr h="265176">
+                <a:tc>
+                  <a:txBody>
+                    <a:bodyPr/>
+                    <a:lstStyle/>
+                    <a:p>
+                      <a:pPr indent="0" marL="0">
+                        <a:buNone/>
+                      </a:pPr>
+                      <a:r>
+                        <a:rPr lang="en-US" sz="1050" b="1" dirty="0">
+                          <a:solidFill>
+                            <a:srgbClr val="1F2937"/>
+                          </a:solidFill>
+                        </a:rPr>
+                        <a:t>Total annual expenditure</a:t>
                       </a:r>
                       <a:endParaRPr lang="en-US" sz="1050" dirty="0"/>
                     </a:p>
@@ -3614,7 +5130,7 @@
                             <a:srgbClr val="1F2937"/>
                           </a:solidFill>
                         </a:rPr>
-                        <a:t>69,600</a:t>
+                        <a:t>111,086</a:t>
                       </a:r>
                       <a:endParaRPr lang="en-US" sz="1050" dirty="0"/>
                     </a:p>
@@ -3657,7 +5173,7 @@
                             <a:srgbClr val="1F2937"/>
                           </a:solidFill>
                         </a:rPr>
-                        <a:t>67,840</a:t>
+                        <a:t>90,440</a:t>
                       </a:r>
                       <a:endParaRPr lang="en-US" sz="1050" dirty="0"/>
                     </a:p>
@@ -3700,7 +5216,7 @@
                             <a:srgbClr val="1F2937"/>
                           </a:solidFill>
                         </a:rPr>
-                        <a:t>71,622</a:t>
+                        <a:t>94,962</a:t>
                       </a:r>
                       <a:endParaRPr lang="en-US" sz="1050" dirty="0"/>
                     </a:p>
@@ -3743,7 +5259,7 @@
                             <a:srgbClr val="1F2937"/>
                           </a:solidFill>
                         </a:rPr>
-                        <a:t>75,623</a:t>
+                        <a:t>102,797</a:t>
                       </a:r>
                       <a:endParaRPr lang="en-US" sz="1050" dirty="0"/>
                     </a:p>
@@ -3786,7 +5302,7 @@
                             <a:srgbClr val="1F2937"/>
                           </a:solidFill>
                         </a:rPr>
-                        <a:t>79,854</a:t>
+                        <a:t>104,696</a:t>
                       </a:r>
                       <a:endParaRPr lang="en-US" sz="1050" dirty="0"/>
                     </a:p>
@@ -3829,1219 +5345,7 @@
                             <a:srgbClr val="1F2937"/>
                           </a:solidFill>
                         </a:rPr>
-                        <a:t>364,539</a:t>
-                      </a:r>
-                      <a:endParaRPr lang="en-US" sz="1050" dirty="0"/>
-                    </a:p>
-                  </a:txBody>
-                  <a:tcPr marL="73152" marR="73152" marT="27432" marB="27432" anchor="ctr">
-                    <a:lnL w="0" cap="flat" cmpd="sng" algn="ctr">
-                      <a:noFill/>
-                    </a:lnL>
-                    <a:lnR w="0" cap="flat" cmpd="sng" algn="ctr">
-                      <a:noFill/>
-                    </a:lnR>
-                    <a:lnT w="0" cap="flat" cmpd="sng" algn="ctr">
-                      <a:noFill/>
-                    </a:lnT>
-                    <a:lnB w="9525" cap="flat" cmpd="sng" algn="ctr">
-                      <a:solidFill>
-                        <a:srgbClr val="D5DCE6"/>
-                      </a:solidFill>
-                      <a:prstDash val="solid"/>
-                      <a:round/>
-                      <a:headEnd type="none" w="med" len="med"/>
-                      <a:tailEnd type="none" w="med" len="med"/>
-                    </a:lnB>
-                    <a:solidFill>
-                      <a:srgbClr val="DDEFF1"/>
-                    </a:solidFill>
-                  </a:tcPr>
-                </a:tc>
-              </a:tr>
-              <a:tr h="283464">
-                <a:tc>
-                  <a:txBody>
-                    <a:bodyPr/>
-                    <a:lstStyle/>
-                    <a:p>
-                      <a:pPr indent="0" marL="0">
-                        <a:buNone/>
-                      </a:pPr>
-                      <a:r>
-                        <a:rPr lang="en-US" sz="1050" dirty="0">
-                          <a:solidFill>
-                            <a:srgbClr val="1F2937"/>
-                          </a:solidFill>
-                        </a:rPr>
-                        <a:t>Preventive maintenance labour (Item 6)</a:t>
-                      </a:r>
-                      <a:endParaRPr lang="en-US" sz="1050" dirty="0"/>
-                    </a:p>
-                  </a:txBody>
-                  <a:tcPr marL="73152" marR="73152" marT="27432" marB="27432" anchor="ctr">
-                    <a:lnL w="0" cap="flat" cmpd="sng" algn="ctr">
-                      <a:noFill/>
-                    </a:lnL>
-                    <a:lnR w="0" cap="flat" cmpd="sng" algn="ctr">
-                      <a:noFill/>
-                    </a:lnR>
-                    <a:lnT w="0" cap="flat" cmpd="sng" algn="ctr">
-                      <a:noFill/>
-                    </a:lnT>
-                    <a:lnB w="9525" cap="flat" cmpd="sng" algn="ctr">
-                      <a:solidFill>
-                        <a:srgbClr val="D5DCE6"/>
-                      </a:solidFill>
-                      <a:prstDash val="solid"/>
-                      <a:round/>
-                      <a:headEnd type="none" w="med" len="med"/>
-                      <a:tailEnd type="none" w="med" len="med"/>
-                    </a:lnB>
-                    <a:solidFill>
-                      <a:srgbClr val="FFFFFF"/>
-                    </a:solidFill>
-                  </a:tcPr>
-                </a:tc>
-                <a:tc>
-                  <a:txBody>
-                    <a:bodyPr/>
-                    <a:lstStyle/>
-                    <a:p>
-                      <a:pPr algn="r" indent="0" marL="0">
-                        <a:buNone/>
-                      </a:pPr>
-                      <a:r>
-                        <a:rPr lang="en-US" sz="1050" dirty="0">
-                          <a:solidFill>
-                            <a:srgbClr val="1F2937"/>
-                          </a:solidFill>
-                        </a:rPr>
-                        <a:t>19,200</a:t>
-                      </a:r>
-                      <a:endParaRPr lang="en-US" sz="1050" dirty="0"/>
-                    </a:p>
-                  </a:txBody>
-                  <a:tcPr marL="73152" marR="73152" marT="27432" marB="27432" anchor="ctr">
-                    <a:lnL w="0" cap="flat" cmpd="sng" algn="ctr">
-                      <a:noFill/>
-                    </a:lnL>
-                    <a:lnR w="0" cap="flat" cmpd="sng" algn="ctr">
-                      <a:noFill/>
-                    </a:lnR>
-                    <a:lnT w="0" cap="flat" cmpd="sng" algn="ctr">
-                      <a:noFill/>
-                    </a:lnT>
-                    <a:lnB w="9525" cap="flat" cmpd="sng" algn="ctr">
-                      <a:solidFill>
-                        <a:srgbClr val="D5DCE6"/>
-                      </a:solidFill>
-                      <a:prstDash val="solid"/>
-                      <a:round/>
-                      <a:headEnd type="none" w="med" len="med"/>
-                      <a:tailEnd type="none" w="med" len="med"/>
-                    </a:lnB>
-                    <a:solidFill>
-                      <a:srgbClr val="FFFFFF"/>
-                    </a:solidFill>
-                  </a:tcPr>
-                </a:tc>
-                <a:tc>
-                  <a:txBody>
-                    <a:bodyPr/>
-                    <a:lstStyle/>
-                    <a:p>
-                      <a:pPr algn="r" indent="0" marL="0">
-                        <a:buNone/>
-                      </a:pPr>
-                      <a:r>
-                        <a:rPr lang="en-US" sz="1050" dirty="0">
-                          <a:solidFill>
-                            <a:srgbClr val="1F2937"/>
-                          </a:solidFill>
-                        </a:rPr>
-                        <a:t>19,800</a:t>
-                      </a:r>
-                      <a:endParaRPr lang="en-US" sz="1050" dirty="0"/>
-                    </a:p>
-                  </a:txBody>
-                  <a:tcPr marL="73152" marR="73152" marT="27432" marB="27432" anchor="ctr">
-                    <a:lnL w="0" cap="flat" cmpd="sng" algn="ctr">
-                      <a:noFill/>
-                    </a:lnL>
-                    <a:lnR w="0" cap="flat" cmpd="sng" algn="ctr">
-                      <a:noFill/>
-                    </a:lnR>
-                    <a:lnT w="0" cap="flat" cmpd="sng" algn="ctr">
-                      <a:noFill/>
-                    </a:lnT>
-                    <a:lnB w="9525" cap="flat" cmpd="sng" algn="ctr">
-                      <a:solidFill>
-                        <a:srgbClr val="D5DCE6"/>
-                      </a:solidFill>
-                      <a:prstDash val="solid"/>
-                      <a:round/>
-                      <a:headEnd type="none" w="med" len="med"/>
-                      <a:tailEnd type="none" w="med" len="med"/>
-                    </a:lnB>
-                    <a:solidFill>
-                      <a:srgbClr val="FFFFFF"/>
-                    </a:solidFill>
-                  </a:tcPr>
-                </a:tc>
-                <a:tc>
-                  <a:txBody>
-                    <a:bodyPr/>
-                    <a:lstStyle/>
-                    <a:p>
-                      <a:pPr algn="r" indent="0" marL="0">
-                        <a:buNone/>
-                      </a:pPr>
-                      <a:r>
-                        <a:rPr lang="en-US" sz="1050" dirty="0">
-                          <a:solidFill>
-                            <a:srgbClr val="1F2937"/>
-                          </a:solidFill>
-                        </a:rPr>
-                        <a:t>20,400</a:t>
-                      </a:r>
-                      <a:endParaRPr lang="en-US" sz="1050" dirty="0"/>
-                    </a:p>
-                  </a:txBody>
-                  <a:tcPr marL="73152" marR="73152" marT="27432" marB="27432" anchor="ctr">
-                    <a:lnL w="0" cap="flat" cmpd="sng" algn="ctr">
-                      <a:noFill/>
-                    </a:lnL>
-                    <a:lnR w="0" cap="flat" cmpd="sng" algn="ctr">
-                      <a:noFill/>
-                    </a:lnR>
-                    <a:lnT w="0" cap="flat" cmpd="sng" algn="ctr">
-                      <a:noFill/>
-                    </a:lnT>
-                    <a:lnB w="9525" cap="flat" cmpd="sng" algn="ctr">
-                      <a:solidFill>
-                        <a:srgbClr val="D5DCE6"/>
-                      </a:solidFill>
-                      <a:prstDash val="solid"/>
-                      <a:round/>
-                      <a:headEnd type="none" w="med" len="med"/>
-                      <a:tailEnd type="none" w="med" len="med"/>
-                    </a:lnB>
-                    <a:solidFill>
-                      <a:srgbClr val="FFFFFF"/>
-                    </a:solidFill>
-                  </a:tcPr>
-                </a:tc>
-                <a:tc>
-                  <a:txBody>
-                    <a:bodyPr/>
-                    <a:lstStyle/>
-                    <a:p>
-                      <a:pPr algn="r" indent="0" marL="0">
-                        <a:buNone/>
-                      </a:pPr>
-                      <a:r>
-                        <a:rPr lang="en-US" sz="1050" dirty="0">
-                          <a:solidFill>
-                            <a:srgbClr val="1F2937"/>
-                          </a:solidFill>
-                        </a:rPr>
-                        <a:t>21,000</a:t>
-                      </a:r>
-                      <a:endParaRPr lang="en-US" sz="1050" dirty="0"/>
-                    </a:p>
-                  </a:txBody>
-                  <a:tcPr marL="73152" marR="73152" marT="27432" marB="27432" anchor="ctr">
-                    <a:lnL w="0" cap="flat" cmpd="sng" algn="ctr">
-                      <a:noFill/>
-                    </a:lnL>
-                    <a:lnR w="0" cap="flat" cmpd="sng" algn="ctr">
-                      <a:noFill/>
-                    </a:lnR>
-                    <a:lnT w="0" cap="flat" cmpd="sng" algn="ctr">
-                      <a:noFill/>
-                    </a:lnT>
-                    <a:lnB w="9525" cap="flat" cmpd="sng" algn="ctr">
-                      <a:solidFill>
-                        <a:srgbClr val="D5DCE6"/>
-                      </a:solidFill>
-                      <a:prstDash val="solid"/>
-                      <a:round/>
-                      <a:headEnd type="none" w="med" len="med"/>
-                      <a:tailEnd type="none" w="med" len="med"/>
-                    </a:lnB>
-                    <a:solidFill>
-                      <a:srgbClr val="FFFFFF"/>
-                    </a:solidFill>
-                  </a:tcPr>
-                </a:tc>
-                <a:tc>
-                  <a:txBody>
-                    <a:bodyPr/>
-                    <a:lstStyle/>
-                    <a:p>
-                      <a:pPr algn="r" indent="0" marL="0">
-                        <a:buNone/>
-                      </a:pPr>
-                      <a:r>
-                        <a:rPr lang="en-US" sz="1050" dirty="0">
-                          <a:solidFill>
-                            <a:srgbClr val="1F2937"/>
-                          </a:solidFill>
-                        </a:rPr>
-                        <a:t>21,600</a:t>
-                      </a:r>
-                      <a:endParaRPr lang="en-US" sz="1050" dirty="0"/>
-                    </a:p>
-                  </a:txBody>
-                  <a:tcPr marL="73152" marR="73152" marT="27432" marB="27432" anchor="ctr">
-                    <a:lnL w="0" cap="flat" cmpd="sng" algn="ctr">
-                      <a:noFill/>
-                    </a:lnL>
-                    <a:lnR w="0" cap="flat" cmpd="sng" algn="ctr">
-                      <a:noFill/>
-                    </a:lnR>
-                    <a:lnT w="0" cap="flat" cmpd="sng" algn="ctr">
-                      <a:noFill/>
-                    </a:lnT>
-                    <a:lnB w="9525" cap="flat" cmpd="sng" algn="ctr">
-                      <a:solidFill>
-                        <a:srgbClr val="D5DCE6"/>
-                      </a:solidFill>
-                      <a:prstDash val="solid"/>
-                      <a:round/>
-                      <a:headEnd type="none" w="med" len="med"/>
-                      <a:tailEnd type="none" w="med" len="med"/>
-                    </a:lnB>
-                    <a:solidFill>
-                      <a:srgbClr val="FFFFFF"/>
-                    </a:solidFill>
-                  </a:tcPr>
-                </a:tc>
-                <a:tc>
-                  <a:txBody>
-                    <a:bodyPr/>
-                    <a:lstStyle/>
-                    <a:p>
-                      <a:pPr algn="r" indent="0" marL="0">
-                        <a:buNone/>
-                      </a:pPr>
-                      <a:r>
-                        <a:rPr lang="en-US" sz="1050" b="1" dirty="0">
-                          <a:solidFill>
-                            <a:srgbClr val="1F2937"/>
-                          </a:solidFill>
-                        </a:rPr>
-                        <a:t>102,000</a:t>
-                      </a:r>
-                      <a:endParaRPr lang="en-US" sz="1050" dirty="0"/>
-                    </a:p>
-                  </a:txBody>
-                  <a:tcPr marL="73152" marR="73152" marT="27432" marB="27432" anchor="ctr">
-                    <a:lnL w="0" cap="flat" cmpd="sng" algn="ctr">
-                      <a:noFill/>
-                    </a:lnL>
-                    <a:lnR w="0" cap="flat" cmpd="sng" algn="ctr">
-                      <a:noFill/>
-                    </a:lnR>
-                    <a:lnT w="0" cap="flat" cmpd="sng" algn="ctr">
-                      <a:noFill/>
-                    </a:lnT>
-                    <a:lnB w="9525" cap="flat" cmpd="sng" algn="ctr">
-                      <a:solidFill>
-                        <a:srgbClr val="D5DCE6"/>
-                      </a:solidFill>
-                      <a:prstDash val="solid"/>
-                      <a:round/>
-                      <a:headEnd type="none" w="med" len="med"/>
-                      <a:tailEnd type="none" w="med" len="med"/>
-                    </a:lnB>
-                    <a:solidFill>
-                      <a:srgbClr val="FFFFFF"/>
-                    </a:solidFill>
-                  </a:tcPr>
-                </a:tc>
-              </a:tr>
-              <a:tr h="283464">
-                <a:tc>
-                  <a:txBody>
-                    <a:bodyPr/>
-                    <a:lstStyle/>
-                    <a:p>
-                      <a:pPr indent="0" marL="0">
-                        <a:buNone/>
-                      </a:pPr>
-                      <a:r>
-                        <a:rPr lang="en-US" sz="1050" b="1" dirty="0">
-                          <a:solidFill>
-                            <a:srgbClr val="FFFFFF"/>
-                          </a:solidFill>
-                        </a:rPr>
-                        <a:t>Total annual operating cost</a:t>
-                      </a:r>
-                      <a:endParaRPr lang="en-US" sz="1050" dirty="0"/>
-                    </a:p>
-                  </a:txBody>
-                  <a:tcPr marL="73152" marR="73152" marT="27432" marB="27432" anchor="ctr">
-                    <a:lnL w="0" cap="flat" cmpd="sng" algn="ctr">
-                      <a:noFill/>
-                    </a:lnL>
-                    <a:lnR w="0" cap="flat" cmpd="sng" algn="ctr">
-                      <a:noFill/>
-                    </a:lnR>
-                    <a:lnT w="0" cap="flat" cmpd="sng" algn="ctr">
-                      <a:noFill/>
-                    </a:lnT>
-                    <a:lnB w="9525" cap="flat" cmpd="sng" algn="ctr">
-                      <a:solidFill>
-                        <a:srgbClr val="D5DCE6"/>
-                      </a:solidFill>
-                      <a:prstDash val="solid"/>
-                      <a:round/>
-                      <a:headEnd type="none" w="med" len="med"/>
-                      <a:tailEnd type="none" w="med" len="med"/>
-                    </a:lnB>
-                    <a:solidFill>
-                      <a:srgbClr val="0B2A4A"/>
-                    </a:solidFill>
-                  </a:tcPr>
-                </a:tc>
-                <a:tc>
-                  <a:txBody>
-                    <a:bodyPr/>
-                    <a:lstStyle/>
-                    <a:p>
-                      <a:pPr algn="r" indent="0" marL="0">
-                        <a:buNone/>
-                      </a:pPr>
-                      <a:r>
-                        <a:rPr lang="en-US" sz="1050" b="1" dirty="0">
-                          <a:solidFill>
-                            <a:srgbClr val="FFFFFF"/>
-                          </a:solidFill>
-                        </a:rPr>
-                        <a:t>88,800</a:t>
-                      </a:r>
-                      <a:endParaRPr lang="en-US" sz="1050" dirty="0"/>
-                    </a:p>
-                  </a:txBody>
-                  <a:tcPr marL="73152" marR="73152" marT="27432" marB="27432" anchor="ctr">
-                    <a:lnL w="0" cap="flat" cmpd="sng" algn="ctr">
-                      <a:noFill/>
-                    </a:lnL>
-                    <a:lnR w="0" cap="flat" cmpd="sng" algn="ctr">
-                      <a:noFill/>
-                    </a:lnR>
-                    <a:lnT w="0" cap="flat" cmpd="sng" algn="ctr">
-                      <a:noFill/>
-                    </a:lnT>
-                    <a:lnB w="9525" cap="flat" cmpd="sng" algn="ctr">
-                      <a:solidFill>
-                        <a:srgbClr val="D5DCE6"/>
-                      </a:solidFill>
-                      <a:prstDash val="solid"/>
-                      <a:round/>
-                      <a:headEnd type="none" w="med" len="med"/>
-                      <a:tailEnd type="none" w="med" len="med"/>
-                    </a:lnB>
-                    <a:solidFill>
-                      <a:srgbClr val="0B2A4A"/>
-                    </a:solidFill>
-                  </a:tcPr>
-                </a:tc>
-                <a:tc>
-                  <a:txBody>
-                    <a:bodyPr/>
-                    <a:lstStyle/>
-                    <a:p>
-                      <a:pPr algn="r" indent="0" marL="0">
-                        <a:buNone/>
-                      </a:pPr>
-                      <a:r>
-                        <a:rPr lang="en-US" sz="1050" b="1" dirty="0">
-                          <a:solidFill>
-                            <a:srgbClr val="FFFFFF"/>
-                          </a:solidFill>
-                        </a:rPr>
-                        <a:t>87,640</a:t>
-                      </a:r>
-                      <a:endParaRPr lang="en-US" sz="1050" dirty="0"/>
-                    </a:p>
-                  </a:txBody>
-                  <a:tcPr marL="73152" marR="73152" marT="27432" marB="27432" anchor="ctr">
-                    <a:lnL w="0" cap="flat" cmpd="sng" algn="ctr">
-                      <a:noFill/>
-                    </a:lnL>
-                    <a:lnR w="0" cap="flat" cmpd="sng" algn="ctr">
-                      <a:noFill/>
-                    </a:lnR>
-                    <a:lnT w="0" cap="flat" cmpd="sng" algn="ctr">
-                      <a:noFill/>
-                    </a:lnT>
-                    <a:lnB w="9525" cap="flat" cmpd="sng" algn="ctr">
-                      <a:solidFill>
-                        <a:srgbClr val="D5DCE6"/>
-                      </a:solidFill>
-                      <a:prstDash val="solid"/>
-                      <a:round/>
-                      <a:headEnd type="none" w="med" len="med"/>
-                      <a:tailEnd type="none" w="med" len="med"/>
-                    </a:lnB>
-                    <a:solidFill>
-                      <a:srgbClr val="0B2A4A"/>
-                    </a:solidFill>
-                  </a:tcPr>
-                </a:tc>
-                <a:tc>
-                  <a:txBody>
-                    <a:bodyPr/>
-                    <a:lstStyle/>
-                    <a:p>
-                      <a:pPr algn="r" indent="0" marL="0">
-                        <a:buNone/>
-                      </a:pPr>
-                      <a:r>
-                        <a:rPr lang="en-US" sz="1050" b="1" dirty="0">
-                          <a:solidFill>
-                            <a:srgbClr val="FFFFFF"/>
-                          </a:solidFill>
-                        </a:rPr>
-                        <a:t>92,022</a:t>
-                      </a:r>
-                      <a:endParaRPr lang="en-US" sz="1050" dirty="0"/>
-                    </a:p>
-                  </a:txBody>
-                  <a:tcPr marL="73152" marR="73152" marT="27432" marB="27432" anchor="ctr">
-                    <a:lnL w="0" cap="flat" cmpd="sng" algn="ctr">
-                      <a:noFill/>
-                    </a:lnL>
-                    <a:lnR w="0" cap="flat" cmpd="sng" algn="ctr">
-                      <a:noFill/>
-                    </a:lnR>
-                    <a:lnT w="0" cap="flat" cmpd="sng" algn="ctr">
-                      <a:noFill/>
-                    </a:lnT>
-                    <a:lnB w="9525" cap="flat" cmpd="sng" algn="ctr">
-                      <a:solidFill>
-                        <a:srgbClr val="D5DCE6"/>
-                      </a:solidFill>
-                      <a:prstDash val="solid"/>
-                      <a:round/>
-                      <a:headEnd type="none" w="med" len="med"/>
-                      <a:tailEnd type="none" w="med" len="med"/>
-                    </a:lnB>
-                    <a:solidFill>
-                      <a:srgbClr val="0B2A4A"/>
-                    </a:solidFill>
-                  </a:tcPr>
-                </a:tc>
-                <a:tc>
-                  <a:txBody>
-                    <a:bodyPr/>
-                    <a:lstStyle/>
-                    <a:p>
-                      <a:pPr algn="r" indent="0" marL="0">
-                        <a:buNone/>
-                      </a:pPr>
-                      <a:r>
-                        <a:rPr lang="en-US" sz="1050" b="1" dirty="0">
-                          <a:solidFill>
-                            <a:srgbClr val="FFFFFF"/>
-                          </a:solidFill>
-                        </a:rPr>
-                        <a:t>96,623</a:t>
-                      </a:r>
-                      <a:endParaRPr lang="en-US" sz="1050" dirty="0"/>
-                    </a:p>
-                  </a:txBody>
-                  <a:tcPr marL="73152" marR="73152" marT="27432" marB="27432" anchor="ctr">
-                    <a:lnL w="0" cap="flat" cmpd="sng" algn="ctr">
-                      <a:noFill/>
-                    </a:lnL>
-                    <a:lnR w="0" cap="flat" cmpd="sng" algn="ctr">
-                      <a:noFill/>
-                    </a:lnR>
-                    <a:lnT w="0" cap="flat" cmpd="sng" algn="ctr">
-                      <a:noFill/>
-                    </a:lnT>
-                    <a:lnB w="9525" cap="flat" cmpd="sng" algn="ctr">
-                      <a:solidFill>
-                        <a:srgbClr val="D5DCE6"/>
-                      </a:solidFill>
-                      <a:prstDash val="solid"/>
-                      <a:round/>
-                      <a:headEnd type="none" w="med" len="med"/>
-                      <a:tailEnd type="none" w="med" len="med"/>
-                    </a:lnB>
-                    <a:solidFill>
-                      <a:srgbClr val="0B2A4A"/>
-                    </a:solidFill>
-                  </a:tcPr>
-                </a:tc>
-                <a:tc>
-                  <a:txBody>
-                    <a:bodyPr/>
-                    <a:lstStyle/>
-                    <a:p>
-                      <a:pPr algn="r" indent="0" marL="0">
-                        <a:buNone/>
-                      </a:pPr>
-                      <a:r>
-                        <a:rPr lang="en-US" sz="1050" b="1" dirty="0">
-                          <a:solidFill>
-                            <a:srgbClr val="FFFFFF"/>
-                          </a:solidFill>
-                        </a:rPr>
-                        <a:t>101,454</a:t>
-                      </a:r>
-                      <a:endParaRPr lang="en-US" sz="1050" dirty="0"/>
-                    </a:p>
-                  </a:txBody>
-                  <a:tcPr marL="73152" marR="73152" marT="27432" marB="27432" anchor="ctr">
-                    <a:lnL w="0" cap="flat" cmpd="sng" algn="ctr">
-                      <a:noFill/>
-                    </a:lnL>
-                    <a:lnR w="0" cap="flat" cmpd="sng" algn="ctr">
-                      <a:noFill/>
-                    </a:lnR>
-                    <a:lnT w="0" cap="flat" cmpd="sng" algn="ctr">
-                      <a:noFill/>
-                    </a:lnT>
-                    <a:lnB w="9525" cap="flat" cmpd="sng" algn="ctr">
-                      <a:solidFill>
-                        <a:srgbClr val="D5DCE6"/>
-                      </a:solidFill>
-                      <a:prstDash val="solid"/>
-                      <a:round/>
-                      <a:headEnd type="none" w="med" len="med"/>
-                      <a:tailEnd type="none" w="med" len="med"/>
-                    </a:lnB>
-                    <a:solidFill>
-                      <a:srgbClr val="0B2A4A"/>
-                    </a:solidFill>
-                  </a:tcPr>
-                </a:tc>
-                <a:tc>
-                  <a:txBody>
-                    <a:bodyPr/>
-                    <a:lstStyle/>
-                    <a:p>
-                      <a:pPr algn="r" indent="0" marL="0">
-                        <a:buNone/>
-                      </a:pPr>
-                      <a:r>
-                        <a:rPr lang="en-US" sz="1050" b="1" dirty="0">
-                          <a:solidFill>
-                            <a:srgbClr val="FFFFFF"/>
-                          </a:solidFill>
-                        </a:rPr>
-                        <a:t>466,539</a:t>
-                      </a:r>
-                      <a:endParaRPr lang="en-US" sz="1050" dirty="0"/>
-                    </a:p>
-                  </a:txBody>
-                  <a:tcPr marL="73152" marR="73152" marT="27432" marB="27432" anchor="ctr">
-                    <a:lnL w="0" cap="flat" cmpd="sng" algn="ctr">
-                      <a:noFill/>
-                    </a:lnL>
-                    <a:lnR w="0" cap="flat" cmpd="sng" algn="ctr">
-                      <a:noFill/>
-                    </a:lnR>
-                    <a:lnT w="0" cap="flat" cmpd="sng" algn="ctr">
-                      <a:noFill/>
-                    </a:lnT>
-                    <a:lnB w="9525" cap="flat" cmpd="sng" algn="ctr">
-                      <a:solidFill>
-                        <a:srgbClr val="D5DCE6"/>
-                      </a:solidFill>
-                      <a:prstDash val="solid"/>
-                      <a:round/>
-                      <a:headEnd type="none" w="med" len="med"/>
-                      <a:tailEnd type="none" w="med" len="med"/>
-                    </a:lnB>
-                    <a:solidFill>
-                      <a:srgbClr val="0B2A4A"/>
-                    </a:solidFill>
-                  </a:tcPr>
-                </a:tc>
-              </a:tr>
-              <a:tr h="283464">
-                <a:tc>
-                  <a:txBody>
-                    <a:bodyPr/>
-                    <a:lstStyle/>
-                    <a:p>
-                      <a:pPr indent="0" marL="0">
-                        <a:buNone/>
-                      </a:pPr>
-                      <a:r>
-                        <a:rPr lang="en-US" sz="1050" i="1" dirty="0">
-                          <a:solidFill>
-                            <a:srgbClr val="7A4F00"/>
-                          </a:solidFill>
-                        </a:rPr>
-                        <a:t>Initial set-up (one-off) – to confirm</a:t>
-                      </a:r>
-                      <a:endParaRPr lang="en-US" sz="1050" dirty="0"/>
-                    </a:p>
-                  </a:txBody>
-                  <a:tcPr marL="73152" marR="73152" marT="27432" marB="27432" anchor="ctr">
-                    <a:lnL w="0" cap="flat" cmpd="sng" algn="ctr">
-                      <a:noFill/>
-                    </a:lnL>
-                    <a:lnR w="0" cap="flat" cmpd="sng" algn="ctr">
-                      <a:noFill/>
-                    </a:lnR>
-                    <a:lnT w="0" cap="flat" cmpd="sng" algn="ctr">
-                      <a:noFill/>
-                    </a:lnT>
-                    <a:lnB w="9525" cap="flat" cmpd="sng" algn="ctr">
-                      <a:solidFill>
-                        <a:srgbClr val="D5DCE6"/>
-                      </a:solidFill>
-                      <a:prstDash val="solid"/>
-                      <a:round/>
-                      <a:headEnd type="none" w="med" len="med"/>
-                      <a:tailEnd type="none" w="med" len="med"/>
-                    </a:lnB>
-                    <a:solidFill>
-                      <a:srgbClr val="FFF4D6"/>
-                    </a:solidFill>
-                  </a:tcPr>
-                </a:tc>
-                <a:tc>
-                  <a:txBody>
-                    <a:bodyPr/>
-                    <a:lstStyle/>
-                    <a:p>
-                      <a:pPr algn="r" indent="0" marL="0">
-                        <a:buNone/>
-                      </a:pPr>
-                      <a:r>
-                        <a:rPr lang="en-US" sz="1050" i="1" dirty="0">
-                          <a:solidFill>
-                            <a:srgbClr val="7A4F00"/>
-                          </a:solidFill>
-                        </a:rPr>
-                        <a:t>14,286</a:t>
-                      </a:r>
-                      <a:endParaRPr lang="en-US" sz="1050" dirty="0"/>
-                    </a:p>
-                  </a:txBody>
-                  <a:tcPr marL="73152" marR="73152" marT="27432" marB="27432" anchor="ctr">
-                    <a:lnL w="0" cap="flat" cmpd="sng" algn="ctr">
-                      <a:noFill/>
-                    </a:lnL>
-                    <a:lnR w="0" cap="flat" cmpd="sng" algn="ctr">
-                      <a:noFill/>
-                    </a:lnR>
-                    <a:lnT w="0" cap="flat" cmpd="sng" algn="ctr">
-                      <a:noFill/>
-                    </a:lnT>
-                    <a:lnB w="9525" cap="flat" cmpd="sng" algn="ctr">
-                      <a:solidFill>
-                        <a:srgbClr val="D5DCE6"/>
-                      </a:solidFill>
-                      <a:prstDash val="solid"/>
-                      <a:round/>
-                      <a:headEnd type="none" w="med" len="med"/>
-                      <a:tailEnd type="none" w="med" len="med"/>
-                    </a:lnB>
-                    <a:solidFill>
-                      <a:srgbClr val="FFF4D6"/>
-                    </a:solidFill>
-                  </a:tcPr>
-                </a:tc>
-                <a:tc>
-                  <a:txBody>
-                    <a:bodyPr/>
-                    <a:lstStyle/>
-                    <a:p>
-                      <a:pPr algn="r" indent="0" marL="0">
-                        <a:buNone/>
-                      </a:pPr>
-                      <a:r>
-                        <a:rPr lang="en-US" sz="1050" dirty="0">
-                          <a:solidFill>
-                            <a:srgbClr val="7A4F00"/>
-                          </a:solidFill>
-                        </a:rPr>
-                        <a:t>–</a:t>
-                      </a:r>
-                      <a:endParaRPr lang="en-US" sz="1050" dirty="0"/>
-                    </a:p>
-                  </a:txBody>
-                  <a:tcPr marL="73152" marR="73152" marT="27432" marB="27432" anchor="ctr">
-                    <a:lnL w="0" cap="flat" cmpd="sng" algn="ctr">
-                      <a:noFill/>
-                    </a:lnL>
-                    <a:lnR w="0" cap="flat" cmpd="sng" algn="ctr">
-                      <a:noFill/>
-                    </a:lnR>
-                    <a:lnT w="0" cap="flat" cmpd="sng" algn="ctr">
-                      <a:noFill/>
-                    </a:lnT>
-                    <a:lnB w="9525" cap="flat" cmpd="sng" algn="ctr">
-                      <a:solidFill>
-                        <a:srgbClr val="D5DCE6"/>
-                      </a:solidFill>
-                      <a:prstDash val="solid"/>
-                      <a:round/>
-                      <a:headEnd type="none" w="med" len="med"/>
-                      <a:tailEnd type="none" w="med" len="med"/>
-                    </a:lnB>
-                    <a:solidFill>
-                      <a:srgbClr val="FFF4D6"/>
-                    </a:solidFill>
-                  </a:tcPr>
-                </a:tc>
-                <a:tc>
-                  <a:txBody>
-                    <a:bodyPr/>
-                    <a:lstStyle/>
-                    <a:p>
-                      <a:pPr algn="r" indent="0" marL="0">
-                        <a:buNone/>
-                      </a:pPr>
-                      <a:r>
-                        <a:rPr lang="en-US" sz="1050" dirty="0">
-                          <a:solidFill>
-                            <a:srgbClr val="7A4F00"/>
-                          </a:solidFill>
-                        </a:rPr>
-                        <a:t>–</a:t>
-                      </a:r>
-                      <a:endParaRPr lang="en-US" sz="1050" dirty="0"/>
-                    </a:p>
-                  </a:txBody>
-                  <a:tcPr marL="73152" marR="73152" marT="27432" marB="27432" anchor="ctr">
-                    <a:lnL w="0" cap="flat" cmpd="sng" algn="ctr">
-                      <a:noFill/>
-                    </a:lnL>
-                    <a:lnR w="0" cap="flat" cmpd="sng" algn="ctr">
-                      <a:noFill/>
-                    </a:lnR>
-                    <a:lnT w="0" cap="flat" cmpd="sng" algn="ctr">
-                      <a:noFill/>
-                    </a:lnT>
-                    <a:lnB w="9525" cap="flat" cmpd="sng" algn="ctr">
-                      <a:solidFill>
-                        <a:srgbClr val="D5DCE6"/>
-                      </a:solidFill>
-                      <a:prstDash val="solid"/>
-                      <a:round/>
-                      <a:headEnd type="none" w="med" len="med"/>
-                      <a:tailEnd type="none" w="med" len="med"/>
-                    </a:lnB>
-                    <a:solidFill>
-                      <a:srgbClr val="FFF4D6"/>
-                    </a:solidFill>
-                  </a:tcPr>
-                </a:tc>
-                <a:tc>
-                  <a:txBody>
-                    <a:bodyPr/>
-                    <a:lstStyle/>
-                    <a:p>
-                      <a:pPr algn="r" indent="0" marL="0">
-                        <a:buNone/>
-                      </a:pPr>
-                      <a:r>
-                        <a:rPr lang="en-US" sz="1050" dirty="0">
-                          <a:solidFill>
-                            <a:srgbClr val="7A4F00"/>
-                          </a:solidFill>
-                        </a:rPr>
-                        <a:t>–</a:t>
-                      </a:r>
-                      <a:endParaRPr lang="en-US" sz="1050" dirty="0"/>
-                    </a:p>
-                  </a:txBody>
-                  <a:tcPr marL="73152" marR="73152" marT="27432" marB="27432" anchor="ctr">
-                    <a:lnL w="0" cap="flat" cmpd="sng" algn="ctr">
-                      <a:noFill/>
-                    </a:lnL>
-                    <a:lnR w="0" cap="flat" cmpd="sng" algn="ctr">
-                      <a:noFill/>
-                    </a:lnR>
-                    <a:lnT w="0" cap="flat" cmpd="sng" algn="ctr">
-                      <a:noFill/>
-                    </a:lnT>
-                    <a:lnB w="9525" cap="flat" cmpd="sng" algn="ctr">
-                      <a:solidFill>
-                        <a:srgbClr val="D5DCE6"/>
-                      </a:solidFill>
-                      <a:prstDash val="solid"/>
-                      <a:round/>
-                      <a:headEnd type="none" w="med" len="med"/>
-                      <a:tailEnd type="none" w="med" len="med"/>
-                    </a:lnB>
-                    <a:solidFill>
-                      <a:srgbClr val="FFF4D6"/>
-                    </a:solidFill>
-                  </a:tcPr>
-                </a:tc>
-                <a:tc>
-                  <a:txBody>
-                    <a:bodyPr/>
-                    <a:lstStyle/>
-                    <a:p>
-                      <a:pPr algn="r" indent="0" marL="0">
-                        <a:buNone/>
-                      </a:pPr>
-                      <a:r>
-                        <a:rPr lang="en-US" sz="1050" dirty="0">
-                          <a:solidFill>
-                            <a:srgbClr val="7A4F00"/>
-                          </a:solidFill>
-                        </a:rPr>
-                        <a:t>–</a:t>
-                      </a:r>
-                      <a:endParaRPr lang="en-US" sz="1050" dirty="0"/>
-                    </a:p>
-                  </a:txBody>
-                  <a:tcPr marL="73152" marR="73152" marT="27432" marB="27432" anchor="ctr">
-                    <a:lnL w="0" cap="flat" cmpd="sng" algn="ctr">
-                      <a:noFill/>
-                    </a:lnL>
-                    <a:lnR w="0" cap="flat" cmpd="sng" algn="ctr">
-                      <a:noFill/>
-                    </a:lnR>
-                    <a:lnT w="0" cap="flat" cmpd="sng" algn="ctr">
-                      <a:noFill/>
-                    </a:lnT>
-                    <a:lnB w="9525" cap="flat" cmpd="sng" algn="ctr">
-                      <a:solidFill>
-                        <a:srgbClr val="D5DCE6"/>
-                      </a:solidFill>
-                      <a:prstDash val="solid"/>
-                      <a:round/>
-                      <a:headEnd type="none" w="med" len="med"/>
-                      <a:tailEnd type="none" w="med" len="med"/>
-                    </a:lnB>
-                    <a:solidFill>
-                      <a:srgbClr val="FFF4D6"/>
-                    </a:solidFill>
-                  </a:tcPr>
-                </a:tc>
-                <a:tc>
-                  <a:txBody>
-                    <a:bodyPr/>
-                    <a:lstStyle/>
-                    <a:p>
-                      <a:pPr algn="r" indent="0" marL="0">
-                        <a:buNone/>
-                      </a:pPr>
-                      <a:r>
-                        <a:rPr lang="en-US" sz="1050" b="1" i="1" dirty="0">
-                          <a:solidFill>
-                            <a:srgbClr val="7A4F00"/>
-                          </a:solidFill>
-                        </a:rPr>
-                        <a:t>14,286</a:t>
-                      </a:r>
-                      <a:endParaRPr lang="en-US" sz="1050" dirty="0"/>
-                    </a:p>
-                  </a:txBody>
-                  <a:tcPr marL="73152" marR="73152" marT="27432" marB="27432" anchor="ctr">
-                    <a:lnL w="0" cap="flat" cmpd="sng" algn="ctr">
-                      <a:noFill/>
-                    </a:lnL>
-                    <a:lnR w="0" cap="flat" cmpd="sng" algn="ctr">
-                      <a:noFill/>
-                    </a:lnR>
-                    <a:lnT w="0" cap="flat" cmpd="sng" algn="ctr">
-                      <a:noFill/>
-                    </a:lnT>
-                    <a:lnB w="9525" cap="flat" cmpd="sng" algn="ctr">
-                      <a:solidFill>
-                        <a:srgbClr val="D5DCE6"/>
-                      </a:solidFill>
-                      <a:prstDash val="solid"/>
-                      <a:round/>
-                      <a:headEnd type="none" w="med" len="med"/>
-                      <a:tailEnd type="none" w="med" len="med"/>
-                    </a:lnB>
-                    <a:solidFill>
-                      <a:srgbClr val="FFF4D6"/>
-                    </a:solidFill>
-                  </a:tcPr>
-                </a:tc>
-              </a:tr>
-              <a:tr h="283464">
-                <a:tc>
-                  <a:txBody>
-                    <a:bodyPr/>
-                    <a:lstStyle/>
-                    <a:p>
-                      <a:pPr indent="0" marL="0">
-                        <a:buNone/>
-                      </a:pPr>
-                      <a:r>
-                        <a:rPr lang="en-US" sz="1050" b="1" dirty="0">
-                          <a:solidFill>
-                            <a:srgbClr val="1F2937"/>
-                          </a:solidFill>
-                        </a:rPr>
-                        <a:t>Total annual expenditure</a:t>
-                      </a:r>
-                      <a:endParaRPr lang="en-US" sz="1050" dirty="0"/>
-                    </a:p>
-                  </a:txBody>
-                  <a:tcPr marL="73152" marR="73152" marT="27432" marB="27432" anchor="ctr">
-                    <a:lnL w="0" cap="flat" cmpd="sng" algn="ctr">
-                      <a:noFill/>
-                    </a:lnL>
-                    <a:lnR w="0" cap="flat" cmpd="sng" algn="ctr">
-                      <a:noFill/>
-                    </a:lnR>
-                    <a:lnT w="0" cap="flat" cmpd="sng" algn="ctr">
-                      <a:noFill/>
-                    </a:lnT>
-                    <a:lnB w="9525" cap="flat" cmpd="sng" algn="ctr">
-                      <a:solidFill>
-                        <a:srgbClr val="D5DCE6"/>
-                      </a:solidFill>
-                      <a:prstDash val="solid"/>
-                      <a:round/>
-                      <a:headEnd type="none" w="med" len="med"/>
-                      <a:tailEnd type="none" w="med" len="med"/>
-                    </a:lnB>
-                    <a:solidFill>
-                      <a:srgbClr val="DDEFF1"/>
-                    </a:solidFill>
-                  </a:tcPr>
-                </a:tc>
-                <a:tc>
-                  <a:txBody>
-                    <a:bodyPr/>
-                    <a:lstStyle/>
-                    <a:p>
-                      <a:pPr algn="r" indent="0" marL="0">
-                        <a:buNone/>
-                      </a:pPr>
-                      <a:r>
-                        <a:rPr lang="en-US" sz="1050" b="1" dirty="0">
-                          <a:solidFill>
-                            <a:srgbClr val="1F2937"/>
-                          </a:solidFill>
-                        </a:rPr>
-                        <a:t>103,086</a:t>
-                      </a:r>
-                      <a:endParaRPr lang="en-US" sz="1050" dirty="0"/>
-                    </a:p>
-                  </a:txBody>
-                  <a:tcPr marL="73152" marR="73152" marT="27432" marB="27432" anchor="ctr">
-                    <a:lnL w="0" cap="flat" cmpd="sng" algn="ctr">
-                      <a:noFill/>
-                    </a:lnL>
-                    <a:lnR w="0" cap="flat" cmpd="sng" algn="ctr">
-                      <a:noFill/>
-                    </a:lnR>
-                    <a:lnT w="0" cap="flat" cmpd="sng" algn="ctr">
-                      <a:noFill/>
-                    </a:lnT>
-                    <a:lnB w="9525" cap="flat" cmpd="sng" algn="ctr">
-                      <a:solidFill>
-                        <a:srgbClr val="D5DCE6"/>
-                      </a:solidFill>
-                      <a:prstDash val="solid"/>
-                      <a:round/>
-                      <a:headEnd type="none" w="med" len="med"/>
-                      <a:tailEnd type="none" w="med" len="med"/>
-                    </a:lnB>
-                    <a:solidFill>
-                      <a:srgbClr val="DDEFF1"/>
-                    </a:solidFill>
-                  </a:tcPr>
-                </a:tc>
-                <a:tc>
-                  <a:txBody>
-                    <a:bodyPr/>
-                    <a:lstStyle/>
-                    <a:p>
-                      <a:pPr algn="r" indent="0" marL="0">
-                        <a:buNone/>
-                      </a:pPr>
-                      <a:r>
-                        <a:rPr lang="en-US" sz="1050" b="1" dirty="0">
-                          <a:solidFill>
-                            <a:srgbClr val="1F2937"/>
-                          </a:solidFill>
-                        </a:rPr>
-                        <a:t>87,640</a:t>
-                      </a:r>
-                      <a:endParaRPr lang="en-US" sz="1050" dirty="0"/>
-                    </a:p>
-                  </a:txBody>
-                  <a:tcPr marL="73152" marR="73152" marT="27432" marB="27432" anchor="ctr">
-                    <a:lnL w="0" cap="flat" cmpd="sng" algn="ctr">
-                      <a:noFill/>
-                    </a:lnL>
-                    <a:lnR w="0" cap="flat" cmpd="sng" algn="ctr">
-                      <a:noFill/>
-                    </a:lnR>
-                    <a:lnT w="0" cap="flat" cmpd="sng" algn="ctr">
-                      <a:noFill/>
-                    </a:lnT>
-                    <a:lnB w="9525" cap="flat" cmpd="sng" algn="ctr">
-                      <a:solidFill>
-                        <a:srgbClr val="D5DCE6"/>
-                      </a:solidFill>
-                      <a:prstDash val="solid"/>
-                      <a:round/>
-                      <a:headEnd type="none" w="med" len="med"/>
-                      <a:tailEnd type="none" w="med" len="med"/>
-                    </a:lnB>
-                    <a:solidFill>
-                      <a:srgbClr val="DDEFF1"/>
-                    </a:solidFill>
-                  </a:tcPr>
-                </a:tc>
-                <a:tc>
-                  <a:txBody>
-                    <a:bodyPr/>
-                    <a:lstStyle/>
-                    <a:p>
-                      <a:pPr algn="r" indent="0" marL="0">
-                        <a:buNone/>
-                      </a:pPr>
-                      <a:r>
-                        <a:rPr lang="en-US" sz="1050" b="1" dirty="0">
-                          <a:solidFill>
-                            <a:srgbClr val="1F2937"/>
-                          </a:solidFill>
-                        </a:rPr>
-                        <a:t>92,022</a:t>
-                      </a:r>
-                      <a:endParaRPr lang="en-US" sz="1050" dirty="0"/>
-                    </a:p>
-                  </a:txBody>
-                  <a:tcPr marL="73152" marR="73152" marT="27432" marB="27432" anchor="ctr">
-                    <a:lnL w="0" cap="flat" cmpd="sng" algn="ctr">
-                      <a:noFill/>
-                    </a:lnL>
-                    <a:lnR w="0" cap="flat" cmpd="sng" algn="ctr">
-                      <a:noFill/>
-                    </a:lnR>
-                    <a:lnT w="0" cap="flat" cmpd="sng" algn="ctr">
-                      <a:noFill/>
-                    </a:lnT>
-                    <a:lnB w="9525" cap="flat" cmpd="sng" algn="ctr">
-                      <a:solidFill>
-                        <a:srgbClr val="D5DCE6"/>
-                      </a:solidFill>
-                      <a:prstDash val="solid"/>
-                      <a:round/>
-                      <a:headEnd type="none" w="med" len="med"/>
-                      <a:tailEnd type="none" w="med" len="med"/>
-                    </a:lnB>
-                    <a:solidFill>
-                      <a:srgbClr val="DDEFF1"/>
-                    </a:solidFill>
-                  </a:tcPr>
-                </a:tc>
-                <a:tc>
-                  <a:txBody>
-                    <a:bodyPr/>
-                    <a:lstStyle/>
-                    <a:p>
-                      <a:pPr algn="r" indent="0" marL="0">
-                        <a:buNone/>
-                      </a:pPr>
-                      <a:r>
-                        <a:rPr lang="en-US" sz="1050" b="1" dirty="0">
-                          <a:solidFill>
-                            <a:srgbClr val="1F2937"/>
-                          </a:solidFill>
-                        </a:rPr>
-                        <a:t>96,623</a:t>
-                      </a:r>
-                      <a:endParaRPr lang="en-US" sz="1050" dirty="0"/>
-                    </a:p>
-                  </a:txBody>
-                  <a:tcPr marL="73152" marR="73152" marT="27432" marB="27432" anchor="ctr">
-                    <a:lnL w="0" cap="flat" cmpd="sng" algn="ctr">
-                      <a:noFill/>
-                    </a:lnL>
-                    <a:lnR w="0" cap="flat" cmpd="sng" algn="ctr">
-                      <a:noFill/>
-                    </a:lnR>
-                    <a:lnT w="0" cap="flat" cmpd="sng" algn="ctr">
-                      <a:noFill/>
-                    </a:lnT>
-                    <a:lnB w="9525" cap="flat" cmpd="sng" algn="ctr">
-                      <a:solidFill>
-                        <a:srgbClr val="D5DCE6"/>
-                      </a:solidFill>
-                      <a:prstDash val="solid"/>
-                      <a:round/>
-                      <a:headEnd type="none" w="med" len="med"/>
-                      <a:tailEnd type="none" w="med" len="med"/>
-                    </a:lnB>
-                    <a:solidFill>
-                      <a:srgbClr val="DDEFF1"/>
-                    </a:solidFill>
-                  </a:tcPr>
-                </a:tc>
-                <a:tc>
-                  <a:txBody>
-                    <a:bodyPr/>
-                    <a:lstStyle/>
-                    <a:p>
-                      <a:pPr algn="r" indent="0" marL="0">
-                        <a:buNone/>
-                      </a:pPr>
-                      <a:r>
-                        <a:rPr lang="en-US" sz="1050" b="1" dirty="0">
-                          <a:solidFill>
-                            <a:srgbClr val="1F2937"/>
-                          </a:solidFill>
-                        </a:rPr>
-                        <a:t>101,454</a:t>
-                      </a:r>
-                      <a:endParaRPr lang="en-US" sz="1050" dirty="0"/>
-                    </a:p>
-                  </a:txBody>
-                  <a:tcPr marL="73152" marR="73152" marT="27432" marB="27432" anchor="ctr">
-                    <a:lnL w="0" cap="flat" cmpd="sng" algn="ctr">
-                      <a:noFill/>
-                    </a:lnL>
-                    <a:lnR w="0" cap="flat" cmpd="sng" algn="ctr">
-                      <a:noFill/>
-                    </a:lnR>
-                    <a:lnT w="0" cap="flat" cmpd="sng" algn="ctr">
-                      <a:noFill/>
-                    </a:lnT>
-                    <a:lnB w="9525" cap="flat" cmpd="sng" algn="ctr">
-                      <a:solidFill>
-                        <a:srgbClr val="D5DCE6"/>
-                      </a:solidFill>
-                      <a:prstDash val="solid"/>
-                      <a:round/>
-                      <a:headEnd type="none" w="med" len="med"/>
-                      <a:tailEnd type="none" w="med" len="med"/>
-                    </a:lnB>
-                    <a:solidFill>
-                      <a:srgbClr val="DDEFF1"/>
-                    </a:solidFill>
-                  </a:tcPr>
-                </a:tc>
-                <a:tc>
-                  <a:txBody>
-                    <a:bodyPr/>
-                    <a:lstStyle/>
-                    <a:p>
-                      <a:pPr algn="r" indent="0" marL="0">
-                        <a:buNone/>
-                      </a:pPr>
-                      <a:r>
-                        <a:rPr lang="en-US" sz="1050" b="1" dirty="0">
-                          <a:solidFill>
-                            <a:srgbClr val="1F2937"/>
-                          </a:solidFill>
-                        </a:rPr>
-                        <a:t>480,825</a:t>
+                        <a:t>503,980</a:t>
                       </a:r>
                       <a:endParaRPr lang="en-US" sz="1050" dirty="0"/>
                     </a:p>
@@ -5084,7 +5388,7 @@
         <p:spPr>
           <a:xfrm>
             <a:off x="8732520" y="2724912"/>
-            <a:ext cx="2907792" cy="3118104"/>
+            <a:ext cx="2907792" cy="3182112"/>
           </a:xfrm>
           <a:prstGeom prst="rect">
             <a:avLst/>
@@ -5139,8 +5443,8 @@
         </p:nvSpPr>
         <p:spPr>
           <a:xfrm>
-            <a:off x="8915400" y="3246120"/>
-            <a:ext cx="2560320" cy="2514600"/>
+            <a:off x="8915400" y="3200400"/>
+            <a:ext cx="2560320" cy="2651760"/>
           </a:xfrm>
           <a:prstGeom prst="rect">
             <a:avLst/>
@@ -5160,14 +5464,14 @@
               <a:buChar char="•"/>
             </a:pPr>
             <a:r>
-              <a:rPr lang="en-US" sz="1100" dirty="0">
+              <a:rPr lang="en-US" sz="1050" dirty="0">
                 <a:solidFill>
                   <a:schemeClr val="bg1"/>
                 </a:solidFill>
               </a:rPr>
               <a:t>Hosting in Singapore with a separate tenancy for each hospital and n+1 redundancy</a:t>
             </a:r>
-            <a:endParaRPr lang="en-US" sz="1100" dirty="0"/>
+            <a:endParaRPr lang="en-US" sz="1050" dirty="0"/>
           </a:p>
           <a:p>
             <a:pPr marL="152400" indent="-152400">
@@ -5178,14 +5482,14 @@
               <a:buChar char="•"/>
             </a:pPr>
             <a:r>
-              <a:rPr lang="en-US" sz="1100" dirty="0">
+              <a:rPr lang="en-US" sz="1050" dirty="0">
                 <a:solidFill>
                   <a:schemeClr val="bg1"/>
                 </a:solidFill>
               </a:rPr>
               <a:t>Encrypted backup, replication and a web application firewall</a:t>
             </a:r>
-            <a:endParaRPr lang="en-US" sz="1100" dirty="0"/>
+            <a:endParaRPr lang="en-US" sz="1050" dirty="0"/>
           </a:p>
           <a:p>
             <a:pPr marL="152400" indent="-152400">
@@ -5196,14 +5500,14 @@
               <a:buChar char="•"/>
             </a:pPr>
             <a:r>
-              <a:rPr lang="en-US" sz="1100" dirty="0">
+              <a:rPr lang="en-US" sz="1050" dirty="0">
                 <a:solidFill>
                   <a:schemeClr val="bg1"/>
                 </a:solidFill>
               </a:rPr>
               <a:t>Annual penetration re-test by a licensed provider</a:t>
             </a:r>
-            <a:endParaRPr lang="en-US" sz="1100" dirty="0"/>
+            <a:endParaRPr lang="en-US" sz="1050" dirty="0"/>
           </a:p>
           <a:p>
             <a:pPr marL="152400" indent="-152400">
@@ -5214,14 +5518,14 @@
               <a:buChar char="•"/>
             </a:pPr>
             <a:r>
-              <a:rPr lang="en-US" sz="1100" dirty="0">
+              <a:rPr lang="en-US" sz="1050" dirty="0">
                 <a:solidFill>
                   <a:schemeClr val="bg1"/>
                 </a:solidFill>
               </a:rPr>
-              <a:t>Remote support, incident response and 24×7 security monitoring</a:t>
+              <a:t>ISO 27001/27017/27018 certification, yearly surveillance audits and Year-4 recertification</a:t>
             </a:r>
-            <a:endParaRPr lang="en-US" sz="1100" dirty="0"/>
+            <a:endParaRPr lang="en-US" sz="1050" dirty="0"/>
           </a:p>
           <a:p>
             <a:pPr marL="152400" indent="-152400">
@@ -5232,14 +5536,32 @@
               <a:buChar char="•"/>
             </a:pPr>
             <a:r>
-              <a:rPr lang="en-US" sz="1100" dirty="0">
+              <a:rPr lang="en-US" sz="1050" dirty="0">
+                <a:solidFill>
+                  <a:schemeClr val="bg1"/>
+                </a:solidFill>
+              </a:rPr>
+              <a:t>Remote support, incident response and 24×7 security monitoring</a:t>
+            </a:r>
+            <a:endParaRPr lang="en-US" sz="1050" dirty="0"/>
+          </a:p>
+          <a:p>
+            <a:pPr marL="152400" indent="-152400">
+              <a:spcAft>
+                <a:spcPts val="500"/>
+              </a:spcAft>
+              <a:buSzPct val="100000"/>
+              <a:buChar char="•"/>
+            </a:pPr>
+            <a:r>
+              <a:rPr lang="en-US" sz="1050" dirty="0">
                 <a:solidFill>
                   <a:schemeClr val="bg1"/>
                 </a:solidFill>
               </a:rPr>
               <a:t>Four preventive-maintenance rounds a year across all three hospitals</a:t>
             </a:r>
-            <a:endParaRPr lang="en-US" sz="1100" dirty="0"/>
+            <a:endParaRPr lang="en-US" sz="1050" dirty="0"/>
           </a:p>
         </p:txBody>
       </p:sp>

</xml_diff>